<commit_message>
Costo de reproceso segun etapa de deteccion (antes/despues de sublimar)
- Costo por metro de ploteo: $2.400/m si se freno antes de sublimar
  (mesa + ploteo 40%) y $6.000/m si ya se sublimo (tela 40% + mesa/ploteo
  40% + sublimacion 20%). Sin evidencia se asume reproceso completo.
- PPT: nueva slide 3 con el desglose; costos may-sep recalculados.
- Maestro: supuestos por etapa, columna Etapa detectada en Datos,
  costo oficial desde metros de ploteo.
- Control de Ploteo v5: columnas Etapa detectada y Costo reproceso,
  bloque de costo por etapa en Dashboard; fila 539 con formulas
  de mes/anio restauradas.

Co-Authored-By: Claude Opus 5.5 <noreply@anthropic.com>
Claude-Session: https://claude.ai/code/session_01TNK5H8UtFdPSdSoNiegNLT
</commit_message>
<xml_diff>
--- a/PMK_Informe_Septiembre2026.pptx
+++ b/PMK_Informe_Septiembre2026.pptx
@@ -7,6 +7,7 @@
   <p:sldIdLst>
     <p:sldId id="256" r:id="rId2"/>
     <p:sldId id="257" r:id="rId3"/>
+    <p:sldId id="263" r:id="rId14"/>
     <p:sldId id="258" r:id="rId4"/>
     <p:sldId id="259" r:id="rId5"/>
     <p:sldId id="260" r:id="rId6"/>
@@ -2755,7 +2756,7 @@
                 <a:ea typeface="Arial" pitchFamily="34" charset="-122"/>
                 <a:cs typeface="Arial" pitchFamily="34" charset="-120"/>
               </a:rPr>
-              <a:t>236 EVENTOS   •   1.045 PRENDAS   •   $7.343.250 CLP COSTO ESTIMADO</a:t>
+              <a:t>236 EVENTOS   •   1.045 PRENDAS   •   $5.416.332 CLP COSTO ESTIMADO</a:t>
             </a:r>
             <a:endParaRPr lang="en-US" sz="1050" dirty="0"/>
           </a:p>
@@ -2922,6 +2923,10 @@
           </a:solidFill>
           <a:ln/>
         </p:spPr>
+        <p:txBody>
+          <a:bodyPr/>
+          <a:p/>
+        </p:txBody>
       </p:sp>
       <p:sp>
         <p:nvSpPr>
@@ -2942,6 +2947,10 @@
           </a:solidFill>
           <a:ln/>
         </p:spPr>
+        <p:txBody>
+          <a:bodyPr/>
+          <a:p/>
+        </p:txBody>
       </p:sp>
       <p:sp>
         <p:nvSpPr>
@@ -2962,6 +2971,10 @@
           </a:solidFill>
           <a:ln/>
         </p:spPr>
+        <p:txBody>
+          <a:bodyPr/>
+          <a:p/>
+        </p:txBody>
       </p:sp>
       <p:sp>
         <p:nvSpPr>
@@ -3035,7 +3048,7 @@
                 <a:ea typeface="Arial" pitchFamily="34" charset="-122"/>
                 <a:cs typeface="Arial" pitchFamily="34" charset="-120"/>
               </a:rPr>
-              <a:t>% reproceso = reproc ÷ (prod+reproc)  |  $6.000 CLP/metro  |  Motivos verificados con chat WA</a:t>
+              <a:t>% reproceso = reproc ÷ (prod+reproc)  |  Costo: $6.000/m si ya se sublimó · $2.400/m si se frenó antes  |  Motivos verificados con chat WA</a:t>
             </a:r>
             <a:endParaRPr lang="en-US" sz="850" dirty="0"/>
           </a:p>
@@ -3060,6 +3073,10 @@
           </a:solidFill>
           <a:ln/>
         </p:spPr>
+        <p:txBody>
+          <a:bodyPr/>
+          <a:p/>
+        </p:txBody>
       </p:sp>
       <p:sp>
         <p:nvSpPr>
@@ -3080,6 +3097,10 @@
           </a:solidFill>
           <a:ln/>
         </p:spPr>
+        <p:txBody>
+          <a:bodyPr/>
+          <a:p/>
+        </p:txBody>
       </p:sp>
       <p:sp>
         <p:nvSpPr>
@@ -3217,6 +3238,10 @@
           </a:solidFill>
           <a:ln/>
         </p:spPr>
+        <p:txBody>
+          <a:bodyPr/>
+          <a:p/>
+        </p:txBody>
       </p:sp>
       <p:sp>
         <p:nvSpPr>
@@ -3237,6 +3262,10 @@
           </a:solidFill>
           <a:ln/>
         </p:spPr>
+        <p:txBody>
+          <a:bodyPr/>
+          <a:p/>
+        </p:txBody>
       </p:sp>
       <p:sp>
         <p:nvSpPr>
@@ -3374,6 +3403,10 @@
           </a:solidFill>
           <a:ln/>
         </p:spPr>
+        <p:txBody>
+          <a:bodyPr/>
+          <a:p/>
+        </p:txBody>
       </p:sp>
       <p:sp>
         <p:nvSpPr>
@@ -3394,6 +3427,10 @@
           </a:solidFill>
           <a:ln/>
         </p:spPr>
+        <p:txBody>
+          <a:bodyPr/>
+          <a:p/>
+        </p:txBody>
       </p:sp>
       <p:sp>
         <p:nvSpPr>
@@ -3531,6 +3568,10 @@
           </a:solidFill>
           <a:ln/>
         </p:spPr>
+        <p:txBody>
+          <a:bodyPr/>
+          <a:p/>
+        </p:txBody>
       </p:sp>
       <p:sp>
         <p:nvSpPr>
@@ -3551,6 +3592,10 @@
           </a:solidFill>
           <a:ln/>
         </p:spPr>
+        <p:txBody>
+          <a:bodyPr/>
+          <a:p/>
+        </p:txBody>
       </p:sp>
       <p:sp>
         <p:nvSpPr>
@@ -3624,7 +3669,7 @@
                 <a:ea typeface="Arial" pitchFamily="34" charset="-122"/>
                 <a:cs typeface="Arial" pitchFamily="34" charset="-120"/>
               </a:rPr>
-              <a:t>$7.343.250</a:t>
+              <a:t>$5.416.332</a:t>
             </a:r>
             <a:endParaRPr lang="en-US" sz="2200" dirty="0"/>
           </a:p>
@@ -3663,7 +3708,7 @@
                 <a:ea typeface="Arial" pitchFamily="34" charset="-122"/>
                 <a:cs typeface="Arial" pitchFamily="34" charset="-120"/>
               </a:rPr>
-              <a:t>CLP mayo–septiembre 2026</a:t>
+              <a:t>CLP may–sep · según etapa</a:t>
             </a:r>
             <a:endParaRPr lang="en-US" sz="800" dirty="0"/>
           </a:p>
@@ -3688,6 +3733,10 @@
           </a:solidFill>
           <a:ln/>
         </p:spPr>
+        <p:txBody>
+          <a:bodyPr/>
+          <a:p/>
+        </p:txBody>
       </p:sp>
       <p:sp>
         <p:nvSpPr>
@@ -3747,6 +3796,10 @@
           </a:solidFill>
           <a:ln/>
         </p:spPr>
+        <p:txBody>
+          <a:bodyPr/>
+          <a:p/>
+        </p:txBody>
       </p:sp>
       <p:sp>
         <p:nvSpPr>
@@ -3806,6 +3859,10 @@
           </a:solidFill>
           <a:ln/>
         </p:spPr>
+        <p:txBody>
+          <a:bodyPr/>
+          <a:p/>
+        </p:txBody>
       </p:sp>
       <p:sp>
         <p:nvSpPr>
@@ -3865,6 +3922,10 @@
           </a:solidFill>
           <a:ln/>
         </p:spPr>
+        <p:txBody>
+          <a:bodyPr/>
+          <a:p/>
+        </p:txBody>
       </p:sp>
       <p:sp>
         <p:nvSpPr>
@@ -3924,6 +3985,10 @@
           </a:solidFill>
           <a:ln/>
         </p:spPr>
+        <p:txBody>
+          <a:bodyPr/>
+          <a:p/>
+        </p:txBody>
       </p:sp>
       <p:sp>
         <p:nvSpPr>
@@ -3983,6 +4048,10 @@
           </a:solidFill>
           <a:ln/>
         </p:spPr>
+        <p:txBody>
+          <a:bodyPr/>
+          <a:p/>
+        </p:txBody>
       </p:sp>
       <p:sp>
         <p:nvSpPr>
@@ -4042,6 +4111,10 @@
           </a:solidFill>
           <a:ln/>
         </p:spPr>
+        <p:txBody>
+          <a:bodyPr/>
+          <a:p/>
+        </p:txBody>
       </p:sp>
       <p:sp>
         <p:nvSpPr>
@@ -4076,7 +4149,7 @@
                 <a:ea typeface="Arial" pitchFamily="34" charset="-122"/>
                 <a:cs typeface="Arial" pitchFamily="34" charset="-120"/>
               </a:rPr>
-              <a:t>COSTO ESTIMADO</a:t>
+              <a:t>COSTO POR ETAPA**</a:t>
             </a:r>
             <a:endParaRPr lang="en-US" sz="700" dirty="0"/>
           </a:p>
@@ -4101,6 +4174,10 @@
           </a:solidFill>
           <a:ln/>
         </p:spPr>
+        <p:txBody>
+          <a:bodyPr/>
+          <a:p/>
+        </p:txBody>
       </p:sp>
       <p:sp>
         <p:nvSpPr>
@@ -4160,6 +4237,10 @@
           </a:solidFill>
           <a:ln/>
         </p:spPr>
+        <p:txBody>
+          <a:bodyPr/>
+          <a:p/>
+        </p:txBody>
       </p:sp>
       <p:sp>
         <p:nvSpPr>
@@ -4219,6 +4300,10 @@
           </a:solidFill>
           <a:ln/>
         </p:spPr>
+        <p:txBody>
+          <a:bodyPr/>
+          <a:p/>
+        </p:txBody>
       </p:sp>
       <p:sp>
         <p:nvSpPr>
@@ -4278,6 +4363,10 @@
           </a:solidFill>
           <a:ln/>
         </p:spPr>
+        <p:txBody>
+          <a:bodyPr/>
+          <a:p/>
+        </p:txBody>
       </p:sp>
       <p:sp>
         <p:nvSpPr>
@@ -4337,6 +4426,10 @@
           </a:solidFill>
           <a:ln/>
         </p:spPr>
+        <p:txBody>
+          <a:bodyPr/>
+          <a:p/>
+        </p:txBody>
       </p:sp>
       <p:sp>
         <p:nvSpPr>
@@ -4396,6 +4489,10 @@
           </a:solidFill>
           <a:ln/>
         </p:spPr>
+        <p:txBody>
+          <a:bodyPr/>
+          <a:p/>
+        </p:txBody>
       </p:sp>
       <p:sp>
         <p:nvSpPr>
@@ -4455,6 +4552,10 @@
           </a:solidFill>
           <a:ln/>
         </p:spPr>
+        <p:txBody>
+          <a:bodyPr/>
+          <a:p/>
+        </p:txBody>
       </p:sp>
       <p:sp>
         <p:nvSpPr>
@@ -4514,6 +4615,10 @@
           </a:solidFill>
           <a:ln/>
         </p:spPr>
+        <p:txBody>
+          <a:bodyPr/>
+          <a:p/>
+        </p:txBody>
       </p:sp>
       <p:sp>
         <p:nvSpPr>
@@ -4548,7 +4653,7 @@
                 <a:ea typeface="Arial" pitchFamily="34" charset="-122"/>
                 <a:cs typeface="Arial" pitchFamily="34" charset="-120"/>
               </a:rPr>
-              <a:t>$337.500</a:t>
+              <a:t>$754.980</a:t>
             </a:r>
             <a:endParaRPr lang="en-US" sz="750" dirty="0"/>
           </a:p>
@@ -4573,6 +4678,10 @@
           </a:solidFill>
           <a:ln/>
         </p:spPr>
+        <p:txBody>
+          <a:bodyPr/>
+          <a:p/>
+        </p:txBody>
       </p:sp>
       <p:sp>
         <p:nvSpPr>
@@ -4632,6 +4741,10 @@
           </a:solidFill>
           <a:ln/>
         </p:spPr>
+        <p:txBody>
+          <a:bodyPr/>
+          <a:p/>
+        </p:txBody>
       </p:sp>
       <p:sp>
         <p:nvSpPr>
@@ -4691,6 +4804,10 @@
           </a:solidFill>
           <a:ln/>
         </p:spPr>
+        <p:txBody>
+          <a:bodyPr/>
+          <a:p/>
+        </p:txBody>
       </p:sp>
       <p:sp>
         <p:nvSpPr>
@@ -4750,6 +4867,10 @@
           </a:solidFill>
           <a:ln/>
         </p:spPr>
+        <p:txBody>
+          <a:bodyPr/>
+          <a:p/>
+        </p:txBody>
       </p:sp>
       <p:sp>
         <p:nvSpPr>
@@ -4809,6 +4930,10 @@
           </a:solidFill>
           <a:ln/>
         </p:spPr>
+        <p:txBody>
+          <a:bodyPr/>
+          <a:p/>
+        </p:txBody>
       </p:sp>
       <p:sp>
         <p:nvSpPr>
@@ -4868,6 +4993,10 @@
           </a:solidFill>
           <a:ln/>
         </p:spPr>
+        <p:txBody>
+          <a:bodyPr/>
+          <a:p/>
+        </p:txBody>
       </p:sp>
       <p:sp>
         <p:nvSpPr>
@@ -4927,6 +5056,10 @@
           </a:solidFill>
           <a:ln/>
         </p:spPr>
+        <p:txBody>
+          <a:bodyPr/>
+          <a:p/>
+        </p:txBody>
       </p:sp>
       <p:sp>
         <p:nvSpPr>
@@ -4986,6 +5119,10 @@
           </a:solidFill>
           <a:ln/>
         </p:spPr>
+        <p:txBody>
+          <a:bodyPr/>
+          <a:p/>
+        </p:txBody>
       </p:sp>
       <p:sp>
         <p:nvSpPr>
@@ -5020,7 +5157,7 @@
                 <a:ea typeface="Arial" pitchFamily="34" charset="-122"/>
                 <a:cs typeface="Arial" pitchFamily="34" charset="-120"/>
               </a:rPr>
-              <a:t>$1.349.250</a:t>
+              <a:t>$861.120</a:t>
             </a:r>
             <a:endParaRPr lang="en-US" sz="750" dirty="0"/>
           </a:p>
@@ -5045,6 +5182,10 @@
           </a:solidFill>
           <a:ln/>
         </p:spPr>
+        <p:txBody>
+          <a:bodyPr/>
+          <a:p/>
+        </p:txBody>
       </p:sp>
       <p:sp>
         <p:nvSpPr>
@@ -5104,6 +5245,10 @@
           </a:solidFill>
           <a:ln/>
         </p:spPr>
+        <p:txBody>
+          <a:bodyPr/>
+          <a:p/>
+        </p:txBody>
       </p:sp>
       <p:sp>
         <p:nvSpPr>
@@ -5163,6 +5308,10 @@
           </a:solidFill>
           <a:ln/>
         </p:spPr>
+        <p:txBody>
+          <a:bodyPr/>
+          <a:p/>
+        </p:txBody>
       </p:sp>
       <p:sp>
         <p:nvSpPr>
@@ -5222,6 +5371,10 @@
           </a:solidFill>
           <a:ln/>
         </p:spPr>
+        <p:txBody>
+          <a:bodyPr/>
+          <a:p/>
+        </p:txBody>
       </p:sp>
       <p:sp>
         <p:nvSpPr>
@@ -5281,6 +5434,10 @@
           </a:solidFill>
           <a:ln/>
         </p:spPr>
+        <p:txBody>
+          <a:bodyPr/>
+          <a:p/>
+        </p:txBody>
       </p:sp>
       <p:sp>
         <p:nvSpPr>
@@ -5340,6 +5497,10 @@
           </a:solidFill>
           <a:ln/>
         </p:spPr>
+        <p:txBody>
+          <a:bodyPr/>
+          <a:p/>
+        </p:txBody>
       </p:sp>
       <p:sp>
         <p:nvSpPr>
@@ -5399,6 +5560,10 @@
           </a:solidFill>
           <a:ln/>
         </p:spPr>
+        <p:txBody>
+          <a:bodyPr/>
+          <a:p/>
+        </p:txBody>
       </p:sp>
       <p:sp>
         <p:nvSpPr>
@@ -5458,6 +5623,10 @@
           </a:solidFill>
           <a:ln/>
         </p:spPr>
+        <p:txBody>
+          <a:bodyPr/>
+          <a:p/>
+        </p:txBody>
       </p:sp>
       <p:sp>
         <p:nvSpPr>
@@ -5492,7 +5661,7 @@
                 <a:ea typeface="Arial" pitchFamily="34" charset="-122"/>
                 <a:cs typeface="Arial" pitchFamily="34" charset="-120"/>
               </a:rPr>
-              <a:t>$1.930.500</a:t>
+              <a:t>$1.422.372</a:t>
             </a:r>
             <a:endParaRPr lang="en-US" sz="750" dirty="0"/>
           </a:p>
@@ -5517,6 +5686,10 @@
           </a:solidFill>
           <a:ln/>
         </p:spPr>
+        <p:txBody>
+          <a:bodyPr/>
+          <a:p/>
+        </p:txBody>
       </p:sp>
       <p:sp>
         <p:nvSpPr>
@@ -5576,6 +5749,10 @@
           </a:solidFill>
           <a:ln/>
         </p:spPr>
+        <p:txBody>
+          <a:bodyPr/>
+          <a:p/>
+        </p:txBody>
       </p:sp>
       <p:sp>
         <p:nvSpPr>
@@ -5635,6 +5812,10 @@
           </a:solidFill>
           <a:ln/>
         </p:spPr>
+        <p:txBody>
+          <a:bodyPr/>
+          <a:p/>
+        </p:txBody>
       </p:sp>
       <p:sp>
         <p:nvSpPr>
@@ -5694,6 +5875,10 @@
           </a:solidFill>
           <a:ln/>
         </p:spPr>
+        <p:txBody>
+          <a:bodyPr/>
+          <a:p/>
+        </p:txBody>
       </p:sp>
       <p:sp>
         <p:nvSpPr>
@@ -5753,6 +5938,10 @@
           </a:solidFill>
           <a:ln/>
         </p:spPr>
+        <p:txBody>
+          <a:bodyPr/>
+          <a:p/>
+        </p:txBody>
       </p:sp>
       <p:sp>
         <p:nvSpPr>
@@ -5812,6 +6001,10 @@
           </a:solidFill>
           <a:ln/>
         </p:spPr>
+        <p:txBody>
+          <a:bodyPr/>
+          <a:p/>
+        </p:txBody>
       </p:sp>
       <p:sp>
         <p:nvSpPr>
@@ -5871,6 +6064,10 @@
           </a:solidFill>
           <a:ln/>
         </p:spPr>
+        <p:txBody>
+          <a:bodyPr/>
+          <a:p/>
+        </p:txBody>
       </p:sp>
       <p:sp>
         <p:nvSpPr>
@@ -5930,6 +6127,10 @@
           </a:solidFill>
           <a:ln/>
         </p:spPr>
+        <p:txBody>
+          <a:bodyPr/>
+          <a:p/>
+        </p:txBody>
       </p:sp>
       <p:sp>
         <p:nvSpPr>
@@ -5964,7 +6165,7 @@
                 <a:ea typeface="Arial" pitchFamily="34" charset="-122"/>
                 <a:cs typeface="Arial" pitchFamily="34" charset="-120"/>
               </a:rPr>
-              <a:t>$1.336.500</a:t>
+              <a:t>$1.636.356</a:t>
             </a:r>
             <a:endParaRPr lang="en-US" sz="750" dirty="0"/>
           </a:p>
@@ -5989,6 +6190,10 @@
           </a:solidFill>
           <a:ln/>
         </p:spPr>
+        <p:txBody>
+          <a:bodyPr/>
+          <a:p/>
+        </p:txBody>
       </p:sp>
       <p:sp>
         <p:nvSpPr>
@@ -6048,6 +6253,10 @@
           </a:solidFill>
           <a:ln/>
         </p:spPr>
+        <p:txBody>
+          <a:bodyPr/>
+          <a:p/>
+        </p:txBody>
       </p:sp>
       <p:sp>
         <p:nvSpPr>
@@ -6107,6 +6316,10 @@
           </a:solidFill>
           <a:ln/>
         </p:spPr>
+        <p:txBody>
+          <a:bodyPr/>
+          <a:p/>
+        </p:txBody>
       </p:sp>
       <p:sp>
         <p:nvSpPr>
@@ -6166,6 +6379,10 @@
           </a:solidFill>
           <a:ln/>
         </p:spPr>
+        <p:txBody>
+          <a:bodyPr/>
+          <a:p/>
+        </p:txBody>
       </p:sp>
       <p:sp>
         <p:nvSpPr>
@@ -6225,6 +6442,10 @@
           </a:solidFill>
           <a:ln/>
         </p:spPr>
+        <p:txBody>
+          <a:bodyPr/>
+          <a:p/>
+        </p:txBody>
       </p:sp>
       <p:sp>
         <p:nvSpPr>
@@ -6284,6 +6505,10 @@
           </a:solidFill>
           <a:ln/>
         </p:spPr>
+        <p:txBody>
+          <a:bodyPr/>
+          <a:p/>
+        </p:txBody>
       </p:sp>
       <p:sp>
         <p:nvSpPr>
@@ -6343,6 +6568,10 @@
           </a:solidFill>
           <a:ln/>
         </p:spPr>
+        <p:txBody>
+          <a:bodyPr/>
+          <a:p/>
+        </p:txBody>
       </p:sp>
       <p:sp>
         <p:nvSpPr>
@@ -6402,6 +6631,10 @@
           </a:solidFill>
           <a:ln/>
         </p:spPr>
+        <p:txBody>
+          <a:bodyPr/>
+          <a:p/>
+        </p:txBody>
       </p:sp>
       <p:sp>
         <p:nvSpPr>
@@ -6436,7 +6669,7 @@
                 <a:ea typeface="Arial" pitchFamily="34" charset="-122"/>
                 <a:cs typeface="Arial" pitchFamily="34" charset="-120"/>
               </a:rPr>
-              <a:t>$2.389.500</a:t>
+              <a:t>$741.504</a:t>
             </a:r>
             <a:endParaRPr lang="en-US" sz="750" dirty="0"/>
           </a:p>
@@ -6908,7 +7141,7 @@
                 <a:ea typeface="Arial" pitchFamily="34" charset="-122"/>
                 <a:cs typeface="Arial" pitchFamily="34" charset="-120"/>
               </a:rPr>
-              <a:t>$7.343.250</a:t>
+              <a:t>$5.416.332</a:t>
             </a:r>
             <a:endParaRPr lang="en-US" sz="750" dirty="0"/>
           </a:p>
@@ -7006,7 +7239,7 @@
                 <a:ea typeface="Arial" pitchFamily="34" charset="-122"/>
                 <a:cs typeface="Arial" pitchFamily="34" charset="-120"/>
               </a:rPr>
-              <a:t>* Julio extrapolado (registro de ploteo incompleto). Mayo y agosto actualizados con Control de Ploteo v4; agosto suma 3 registros WA del 31-ago. Costo = prendas × 1,125 m × $6.000/m (papel, ploteo y sublimación).</a:t>
+              <a:t>* Julio extrapolado (registro de ploteo incompleto). Mayo y agosto actualizados con Control de Ploteo v4; agosto suma 3 registros WA del 31-ago.</a:t>
             </a:r>
             <a:endParaRPr lang="en-US" sz="700" dirty="0"/>
           </a:p>
@@ -7023,7 +7256,7 @@
                 <a:ea typeface="Arial" pitchFamily="34" charset="-122"/>
                 <a:cs typeface="Arial" pitchFamily="34" charset="-120"/>
               </a:rPr>
-              <a:t>** Sep.: 4 registros de paños/piezas (Geología 70 cuellos, Vosterh 58 camisetas, Rugby Maule 50 patas, Mackay 31 patas) = $1.410.750 del costo. Por metros de ploteo: 127 m × $6.000 = $762.780.</a:t>
+              <a:t>** Costo = metros de reproceso del Control de Ploteo × $6.000/m si la pieza ya se había sublimado, o × $2.400/m si se frenó antes de sublimar (sólo armado de mesa + ploteo). Sin evidencia de la etapa se asume reproceso completo. Detalle en la slide 3.</a:t>
             </a:r>
             <a:endParaRPr lang="en-US" sz="700" dirty="0"/>
           </a:p>
@@ -8101,7 +8334,7 @@
                 <a:ea typeface="Arial" pitchFamily="34" charset="-122"/>
                 <a:cs typeface="Arial" pitchFamily="34" charset="-120"/>
               </a:rPr>
-              <a:t>COSTO ESTIMADO ACUMULADO</a:t>
+              <a:t>COSTO ACUMULADO (SEGÚN ETAPA)</a:t>
             </a:r>
             <a:endParaRPr lang="en-US" sz="800" dirty="0"/>
           </a:p>
@@ -8140,7 +8373,7 @@
                 <a:ea typeface="Arial" pitchFamily="34" charset="-122"/>
                 <a:cs typeface="Arial" pitchFamily="34" charset="-120"/>
               </a:rPr>
-              <a:t>$7.343.250 CLP</a:t>
+              <a:t>$5.416.332 CLP</a:t>
             </a:r>
             <a:endParaRPr lang="en-US" sz="1600" dirty="0"/>
           </a:p>
@@ -13192,7 +13425,7 @@
                 <a:ea typeface="Arial" pitchFamily="34" charset="-122"/>
                 <a:cs typeface="Arial" pitchFamily="34" charset="-120"/>
               </a:rPr>
-              <a:t>Unificar categorías entre sistemas</a:t>
+              <a:t>Unificar categorías y registrar etapa</a:t>
             </a:r>
             <a:endParaRPr lang="en-US" sz="1000" dirty="0"/>
           </a:p>
@@ -13231,7 +13464,7 @@
                 <a:ea typeface="Arial" pitchFamily="34" charset="-122"/>
                 <a:cs typeface="Arial" pitchFamily="34" charset="-120"/>
               </a:rPr>
-              <a:t>Mesa/Papel (WA) = Error en mesa + Falta de paño + Banding (Ploteo). Diccionario común.</a:t>
+              <a:t>Mesa/Papel (WA) = Error en mesa + Falta de paño + Banding. Nueva columna "Etapa detectada" (antes/después de sublimar) en Control de Ploteo y línea ETAPA en WA.</a:t>
             </a:r>
             <a:endParaRPr lang="en-US" sz="850" dirty="0"/>
           </a:p>
@@ -13798,7 +14031,7 @@
                 <a:ea typeface="Arial" pitchFamily="34" charset="-122"/>
                 <a:cs typeface="Arial" pitchFamily="34" charset="-120"/>
               </a:rPr>
-              <a:t>$7.343.250 CLP costo estimado   |   933m reprocesados   |   80 eventos Mesa/Papel   |   Meta: ≤100m/mes dic. 2026</a:t>
+              <a:t>$5.416.332 CLP costo estimado   |   933m reprocesados   |   80 eventos Mesa/Papel   |   Meta: ≤100m/mes dic. 2026</a:t>
             </a:r>
             <a:endParaRPr lang="en-US" sz="1000" dirty="0"/>
           </a:p>
@@ -13840,6 +14073,2822 @@
               <a:t>UN CLUB, UNA FAMILIA   |   www.playmaker.cl</a:t>
             </a:r>
             <a:endParaRPr lang="en-US" sz="850" dirty="0"/>
+          </a:p>
+        </p:txBody>
+      </p:sp>
+    </p:spTree>
+  </p:cSld>
+  <p:clrMapOvr>
+    <a:masterClrMapping/>
+  </p:clrMapOvr>
+</p:sld>
+</file>
+
+<file path=ppt/slides/slide8.xml><?xml version="1.0" encoding="utf-8"?>
+<p:sld xmlns:a="http://schemas.openxmlformats.org/drawingml/2006/main" xmlns:p="http://schemas.openxmlformats.org/presentationml/2006/main" xmlns:r="http://schemas.openxmlformats.org/officeDocument/2006/relationships">
+  <p:cSld>
+    <p:spTree>
+      <p:nvGrpSpPr>
+        <p:cNvPr id="1" name=""/>
+        <p:cNvGrpSpPr/>
+        <p:nvPr/>
+      </p:nvGrpSpPr>
+      <p:grpSpPr/>
+      <p:sp>
+        <p:nvSpPr>
+          <p:cNvPr id="2001" name="Shape 2001"/>
+          <p:cNvSpPr/>
+          <p:nvPr/>
+        </p:nvSpPr>
+        <p:spPr>
+          <a:xfrm>
+            <a:off x="0" y="0"/>
+            <a:ext cx="9144000" cy="5143500"/>
+          </a:xfrm>
+          <a:prstGeom prst="rect">
+            <a:avLst/>
+          </a:prstGeom>
+          <a:solidFill>
+            <a:srgbClr val="000000"/>
+          </a:solidFill>
+          <a:ln/>
+        </p:spPr>
+      </p:sp>
+      <p:sp>
+        <p:nvSpPr>
+          <p:cNvPr id="2002" name="Shape 2002"/>
+          <p:cNvSpPr/>
+          <p:nvPr/>
+        </p:nvSpPr>
+        <p:spPr>
+          <a:xfrm>
+            <a:off x="0" y="0"/>
+            <a:ext cx="9144000" cy="749808"/>
+          </a:xfrm>
+          <a:prstGeom prst="rect">
+            <a:avLst/>
+          </a:prstGeom>
+          <a:solidFill>
+            <a:srgbClr val="2D2D2D"/>
+          </a:solidFill>
+          <a:ln/>
+        </p:spPr>
+      </p:sp>
+      <p:sp>
+        <p:nvSpPr>
+          <p:cNvPr id="2003" name="Shape 2003"/>
+          <p:cNvSpPr/>
+          <p:nvPr/>
+        </p:nvSpPr>
+        <p:spPr>
+          <a:xfrm>
+            <a:off x="0" y="0"/>
+            <a:ext cx="54864" cy="749808"/>
+          </a:xfrm>
+          <a:prstGeom prst="rect">
+            <a:avLst/>
+          </a:prstGeom>
+          <a:solidFill>
+            <a:srgbClr val="ED6C23"/>
+          </a:solidFill>
+          <a:ln/>
+        </p:spPr>
+      </p:sp>
+      <p:sp>
+        <p:nvSpPr>
+          <p:cNvPr id="2004" name="Shape 2004"/>
+          <p:cNvSpPr txBox="1"/>
+          <p:nvPr/>
+        </p:nvSpPr>
+        <p:spPr>
+          <a:xfrm>
+            <a:off x="228600" y="146304"/>
+            <a:ext cx="7772400" cy="347472"/>
+          </a:xfrm>
+          <a:prstGeom prst="rect">
+            <a:avLst/>
+          </a:prstGeom>
+          <a:noFill/>
+          <a:ln/>
+        </p:spPr>
+        <p:txBody>
+          <a:bodyPr wrap="square" lIns="0" tIns="0" rIns="0" bIns="0" rtlCol="0" anchor="t"/>
+          <a:lstStyle/>
+          <a:p>
+            <a:pPr algn="l" indent="0" marL="0">
+              <a:buNone/>
+            </a:pPr>
+            <a:r>
+              <a:rPr lang="en-US" sz="1600" b="1" dirty="0">
+                <a:solidFill>
+                  <a:srgbClr val="FFFFFF"/>
+                </a:solidFill>
+                <a:latin typeface="Arial" pitchFamily="34" charset="0"/>
+                <a:ea typeface="Arial" pitchFamily="34" charset="-122"/>
+                <a:cs typeface="Arial" pitchFamily="34" charset="-120"/>
+              </a:rPr>
+              <a:t>COSTO DE REPROCESO — SEGÚN ETAPA DE DETECCIÓN</a:t>
+            </a:r>
+            <a:endParaRPr lang="en-US" sz="1600" dirty="0"/>
+          </a:p>
+        </p:txBody>
+      </p:sp>
+      <p:sp>
+        <p:nvSpPr>
+          <p:cNvPr id="2005" name="Shape 2005"/>
+          <p:cNvSpPr txBox="1"/>
+          <p:nvPr/>
+        </p:nvSpPr>
+        <p:spPr>
+          <a:xfrm>
+            <a:off x="228600" y="457200"/>
+            <a:ext cx="8229600" cy="219456"/>
+          </a:xfrm>
+          <a:prstGeom prst="rect">
+            <a:avLst/>
+          </a:prstGeom>
+          <a:noFill/>
+          <a:ln/>
+        </p:spPr>
+        <p:txBody>
+          <a:bodyPr wrap="square" lIns="0" tIns="0" rIns="0" bIns="0" rtlCol="0" anchor="t"/>
+          <a:lstStyle/>
+          <a:p>
+            <a:pPr algn="l" indent="0" marL="0">
+              <a:buNone/>
+            </a:pPr>
+            <a:r>
+              <a:rPr lang="en-US" sz="850" i="1" dirty="0">
+                <a:solidFill>
+                  <a:srgbClr val="9A9A9A"/>
+                </a:solidFill>
+                <a:latin typeface="Arial" pitchFamily="34" charset="0"/>
+                <a:ea typeface="Arial" pitchFamily="34" charset="-122"/>
+                <a:cs typeface="Arial" pitchFamily="34" charset="-120"/>
+              </a:rPr>
+              <a:t>Costo por metro $6.000 = tela 40% + armado de mesa y ploteo 40% + sublimación 20%   |   Metros reales del Control de Ploteo</a:t>
+            </a:r>
+            <a:endParaRPr lang="en-US" sz="850" dirty="0"/>
+          </a:p>
+        </p:txBody>
+      </p:sp>
+      <p:sp>
+        <p:nvSpPr>
+          <p:cNvPr id="2006" name="Shape 2006"/>
+          <p:cNvSpPr txBox="1"/>
+          <p:nvPr/>
+        </p:nvSpPr>
+        <p:spPr>
+          <a:xfrm>
+            <a:off x="164592" y="868680"/>
+            <a:ext cx="5486400" cy="219456"/>
+          </a:xfrm>
+          <a:prstGeom prst="rect">
+            <a:avLst/>
+          </a:prstGeom>
+          <a:noFill/>
+          <a:ln/>
+        </p:spPr>
+        <p:txBody>
+          <a:bodyPr wrap="square" lIns="0" tIns="0" rIns="0" bIns="0" rtlCol="0" anchor="t"/>
+          <a:lstStyle/>
+          <a:p>
+            <a:pPr algn="l" indent="0" marL="0">
+              <a:buNone/>
+            </a:pPr>
+            <a:r>
+              <a:rPr lang="en-US" sz="900" b="1" dirty="0">
+                <a:solidFill>
+                  <a:srgbClr val="ED6C23"/>
+                </a:solidFill>
+                <a:latin typeface="Arial" pitchFamily="34" charset="0"/>
+                <a:ea typeface="Arial" pitchFamily="34" charset="-122"/>
+                <a:cs typeface="Arial" pitchFamily="34" charset="-120"/>
+              </a:rPr>
+              <a:t>¿QUÉ SE PIERDE EN CADA REPROCESO?  (por metro)</a:t>
+            </a:r>
+            <a:endParaRPr lang="en-US" sz="1100" dirty="0"/>
+          </a:p>
+        </p:txBody>
+      </p:sp>
+      <p:sp>
+        <p:nvSpPr>
+          <p:cNvPr id="2007" name="Shape 2007"/>
+          <p:cNvSpPr/>
+          <p:nvPr/>
+        </p:nvSpPr>
+        <p:spPr>
+          <a:xfrm>
+            <a:off x="164592" y="1133856"/>
+            <a:ext cx="3498494" cy="384048"/>
+          </a:xfrm>
+          <a:prstGeom prst="rect">
+            <a:avLst/>
+          </a:prstGeom>
+          <a:solidFill>
+            <a:srgbClr val="1B7F4A"/>
+          </a:solidFill>
+          <a:ln/>
+        </p:spPr>
+        <p:txBody>
+          <a:bodyPr/>
+          <a:p/>
+        </p:txBody>
+      </p:sp>
+      <p:sp>
+        <p:nvSpPr>
+          <p:cNvPr id="2008" name="Shape 2008"/>
+          <p:cNvSpPr txBox="1"/>
+          <p:nvPr/>
+        </p:nvSpPr>
+        <p:spPr>
+          <a:xfrm>
+            <a:off x="210312" y="1170432"/>
+            <a:ext cx="3407054" cy="310896"/>
+          </a:xfrm>
+          <a:prstGeom prst="rect">
+            <a:avLst/>
+          </a:prstGeom>
+          <a:noFill/>
+          <a:ln/>
+        </p:spPr>
+        <p:txBody>
+          <a:bodyPr wrap="square" lIns="0" tIns="0" rIns="0" bIns="0" rtlCol="0" anchor="ctr"/>
+          <a:lstStyle/>
+          <a:p>
+            <a:pPr algn="ctr" indent="0" marL="0">
+              <a:buNone/>
+            </a:pPr>
+            <a:r>
+              <a:rPr lang="en-US" sz="800" b="1" dirty="0">
+                <a:solidFill>
+                  <a:srgbClr val="FFFFFF"/>
+                </a:solidFill>
+                <a:latin typeface="Arial" pitchFamily="34" charset="0"/>
+                <a:ea typeface="Arial" pitchFamily="34" charset="-122"/>
+                <a:cs typeface="Arial" pitchFamily="34" charset="-120"/>
+              </a:rPr>
+              <a:t>ARMADO DE MESA + PLOTEO  ·  40%  ·  $2.400</a:t>
+            </a:r>
+            <a:endParaRPr lang="en-US" sz="700" dirty="0"/>
+          </a:p>
+        </p:txBody>
+      </p:sp>
+      <p:sp>
+        <p:nvSpPr>
+          <p:cNvPr id="2009" name="Shape 2009"/>
+          <p:cNvSpPr/>
+          <p:nvPr/>
+        </p:nvSpPr>
+        <p:spPr>
+          <a:xfrm>
+            <a:off x="3690518" y="1133856"/>
+            <a:ext cx="3498494" cy="384048"/>
+          </a:xfrm>
+          <a:prstGeom prst="rect">
+            <a:avLst/>
+          </a:prstGeom>
+          <a:solidFill>
+            <a:srgbClr val="ED6C23"/>
+          </a:solidFill>
+          <a:ln/>
+        </p:spPr>
+        <p:txBody>
+          <a:bodyPr/>
+          <a:p/>
+        </p:txBody>
+      </p:sp>
+      <p:sp>
+        <p:nvSpPr>
+          <p:cNvPr id="2010" name="Shape 2010"/>
+          <p:cNvSpPr txBox="1"/>
+          <p:nvPr/>
+        </p:nvSpPr>
+        <p:spPr>
+          <a:xfrm>
+            <a:off x="3736238" y="1170432"/>
+            <a:ext cx="3407054" cy="310896"/>
+          </a:xfrm>
+          <a:prstGeom prst="rect">
+            <a:avLst/>
+          </a:prstGeom>
+          <a:noFill/>
+          <a:ln/>
+        </p:spPr>
+        <p:txBody>
+          <a:bodyPr wrap="square" lIns="0" tIns="0" rIns="0" bIns="0" rtlCol="0" anchor="ctr"/>
+          <a:lstStyle/>
+          <a:p>
+            <a:pPr algn="ctr" indent="0" marL="0">
+              <a:buNone/>
+            </a:pPr>
+            <a:r>
+              <a:rPr lang="en-US" sz="800" b="1" dirty="0">
+                <a:solidFill>
+                  <a:srgbClr val="000000"/>
+                </a:solidFill>
+                <a:latin typeface="Arial" pitchFamily="34" charset="0"/>
+                <a:ea typeface="Arial" pitchFamily="34" charset="-122"/>
+                <a:cs typeface="Arial" pitchFamily="34" charset="-120"/>
+              </a:rPr>
+              <a:t>TELA  ·  40%  ·  $2.400</a:t>
+            </a:r>
+            <a:endParaRPr lang="en-US" sz="700" dirty="0"/>
+          </a:p>
+        </p:txBody>
+      </p:sp>
+      <p:sp>
+        <p:nvSpPr>
+          <p:cNvPr id="2011" name="Shape 2011"/>
+          <p:cNvSpPr/>
+          <p:nvPr/>
+        </p:nvSpPr>
+        <p:spPr>
+          <a:xfrm>
+            <a:off x="7216445" y="1133856"/>
+            <a:ext cx="1762963" cy="384048"/>
+          </a:xfrm>
+          <a:prstGeom prst="rect">
+            <a:avLst/>
+          </a:prstGeom>
+          <a:solidFill>
+            <a:srgbClr val="B4501A"/>
+          </a:solidFill>
+          <a:ln/>
+        </p:spPr>
+        <p:txBody>
+          <a:bodyPr/>
+          <a:p/>
+        </p:txBody>
+      </p:sp>
+      <p:sp>
+        <p:nvSpPr>
+          <p:cNvPr id="2012" name="Shape 2012"/>
+          <p:cNvSpPr txBox="1"/>
+          <p:nvPr/>
+        </p:nvSpPr>
+        <p:spPr>
+          <a:xfrm>
+            <a:off x="7262165" y="1170432"/>
+            <a:ext cx="1671523" cy="310896"/>
+          </a:xfrm>
+          <a:prstGeom prst="rect">
+            <a:avLst/>
+          </a:prstGeom>
+          <a:noFill/>
+          <a:ln/>
+        </p:spPr>
+        <p:txBody>
+          <a:bodyPr wrap="square" lIns="0" tIns="0" rIns="0" bIns="0" rtlCol="0" anchor="ctr"/>
+          <a:lstStyle/>
+          <a:p>
+            <a:pPr algn="ctr" indent="0" marL="0">
+              <a:buNone/>
+            </a:pPr>
+            <a:r>
+              <a:rPr lang="en-US" sz="800" b="1" dirty="0">
+                <a:solidFill>
+                  <a:srgbClr val="FFFFFF"/>
+                </a:solidFill>
+                <a:latin typeface="Arial" pitchFamily="34" charset="0"/>
+                <a:ea typeface="Arial" pitchFamily="34" charset="-122"/>
+                <a:cs typeface="Arial" pitchFamily="34" charset="-120"/>
+              </a:rPr>
+              <a:t>SUBLIMACIÓN  ·  20%  ·  $1.200</a:t>
+            </a:r>
+            <a:endParaRPr lang="en-US" sz="700" dirty="0"/>
+          </a:p>
+        </p:txBody>
+      </p:sp>
+      <p:sp>
+        <p:nvSpPr>
+          <p:cNvPr id="2013" name="Shape 2013"/>
+          <p:cNvSpPr txBox="1"/>
+          <p:nvPr/>
+        </p:nvSpPr>
+        <p:spPr>
+          <a:xfrm>
+            <a:off x="164592" y="1591056"/>
+            <a:ext cx="3529584" cy="201168"/>
+          </a:xfrm>
+          <a:prstGeom prst="rect">
+            <a:avLst/>
+          </a:prstGeom>
+          <a:noFill/>
+          <a:ln/>
+        </p:spPr>
+        <p:txBody>
+          <a:bodyPr wrap="square" lIns="0" tIns="0" rIns="0" bIns="0" rtlCol="0" anchor="t"/>
+          <a:lstStyle/>
+          <a:p>
+            <a:pPr algn="l" indent="0" marL="0">
+              <a:buNone/>
+            </a:pPr>
+            <a:r>
+              <a:rPr lang="en-US" sz="800" b="1" dirty="0">
+                <a:solidFill>
+                  <a:srgbClr val="27AE60"/>
+                </a:solidFill>
+                <a:latin typeface="Arial" pitchFamily="34" charset="0"/>
+                <a:ea typeface="Arial" pitchFamily="34" charset="-122"/>
+                <a:cs typeface="Arial" pitchFamily="34" charset="-120"/>
+              </a:rPr>
+              <a:t>▲ FRENADO ANTES DE SUBLIMAR → sólo se reimprime: $2.400/m</a:t>
+            </a:r>
+            <a:endParaRPr lang="en-US" sz="750" dirty="0"/>
+          </a:p>
+        </p:txBody>
+      </p:sp>
+      <p:sp>
+        <p:nvSpPr>
+          <p:cNvPr id="2014" name="Shape 2014"/>
+          <p:cNvSpPr txBox="1"/>
+          <p:nvPr/>
+        </p:nvSpPr>
+        <p:spPr>
+          <a:xfrm>
+            <a:off x="3694176" y="1591056"/>
+            <a:ext cx="5285232" cy="201168"/>
+          </a:xfrm>
+          <a:prstGeom prst="rect">
+            <a:avLst/>
+          </a:prstGeom>
+          <a:noFill/>
+          <a:ln/>
+        </p:spPr>
+        <p:txBody>
+          <a:bodyPr wrap="square" lIns="0" tIns="0" rIns="0" bIns="0" rtlCol="0" anchor="t"/>
+          <a:lstStyle/>
+          <a:p>
+            <a:pPr algn="r" indent="0" marL="0">
+              <a:buNone/>
+            </a:pPr>
+            <a:r>
+              <a:rPr lang="en-US" sz="800" b="1" dirty="0">
+                <a:solidFill>
+                  <a:srgbClr val="ED6C23"/>
+                </a:solidFill>
+                <a:latin typeface="Arial" pitchFamily="34" charset="0"/>
+                <a:ea typeface="Arial" pitchFamily="34" charset="-122"/>
+                <a:cs typeface="Arial" pitchFamily="34" charset="-120"/>
+              </a:rPr>
+              <a:t>YA SUBLIMADO → se pierden las 3 partes: $6.000/m ▲</a:t>
+            </a:r>
+            <a:endParaRPr lang="en-US" sz="750" dirty="0"/>
+          </a:p>
+        </p:txBody>
+      </p:sp>
+      <p:sp>
+        <p:nvSpPr>
+          <p:cNvPr id="2015" name="Shape 2015"/>
+          <p:cNvSpPr/>
+          <p:nvPr/>
+        </p:nvSpPr>
+        <p:spPr>
+          <a:xfrm>
+            <a:off x="164592" y="1938528"/>
+            <a:ext cx="1188720" cy="310896"/>
+          </a:xfrm>
+          <a:prstGeom prst="rect">
+            <a:avLst/>
+          </a:prstGeom>
+          <a:solidFill>
+            <a:srgbClr val="ED6C23"/>
+          </a:solidFill>
+          <a:ln/>
+        </p:spPr>
+        <p:txBody>
+          <a:bodyPr/>
+          <a:p/>
+        </p:txBody>
+      </p:sp>
+      <p:sp>
+        <p:nvSpPr>
+          <p:cNvPr id="2016" name="Shape 2016"/>
+          <p:cNvSpPr txBox="1"/>
+          <p:nvPr/>
+        </p:nvSpPr>
+        <p:spPr>
+          <a:xfrm>
+            <a:off x="201168" y="1965960"/>
+            <a:ext cx="1115568" cy="256032"/>
+          </a:xfrm>
+          <a:prstGeom prst="rect">
+            <a:avLst/>
+          </a:prstGeom>
+          <a:noFill/>
+          <a:ln/>
+        </p:spPr>
+        <p:txBody>
+          <a:bodyPr wrap="square" lIns="0" tIns="0" rIns="0" bIns="0" rtlCol="0" anchor="ctr"/>
+          <a:lstStyle/>
+          <a:p>
+            <a:pPr algn="ctr" indent="0" marL="0">
+              <a:buNone/>
+            </a:pPr>
+            <a:r>
+              <a:rPr lang="en-US" sz="700" b="1" dirty="0">
+                <a:solidFill>
+                  <a:srgbClr val="000000"/>
+                </a:solidFill>
+                <a:latin typeface="Arial" pitchFamily="34" charset="0"/>
+                <a:ea typeface="Arial" pitchFamily="34" charset="-122"/>
+                <a:cs typeface="Arial" pitchFamily="34" charset="-120"/>
+              </a:rPr>
+              <a:t>MES</a:t>
+            </a:r>
+            <a:endParaRPr lang="en-US" sz="700" dirty="0"/>
+          </a:p>
+        </p:txBody>
+      </p:sp>
+      <p:sp>
+        <p:nvSpPr>
+          <p:cNvPr id="2017" name="Shape 2017"/>
+          <p:cNvSpPr/>
+          <p:nvPr/>
+        </p:nvSpPr>
+        <p:spPr>
+          <a:xfrm>
+            <a:off x="1353312" y="1938528"/>
+            <a:ext cx="1005840" cy="310896"/>
+          </a:xfrm>
+          <a:prstGeom prst="rect">
+            <a:avLst/>
+          </a:prstGeom>
+          <a:solidFill>
+            <a:srgbClr val="ED6C23"/>
+          </a:solidFill>
+          <a:ln/>
+        </p:spPr>
+        <p:txBody>
+          <a:bodyPr/>
+          <a:p/>
+        </p:txBody>
+      </p:sp>
+      <p:sp>
+        <p:nvSpPr>
+          <p:cNvPr id="2018" name="Shape 2018"/>
+          <p:cNvSpPr txBox="1"/>
+          <p:nvPr/>
+        </p:nvSpPr>
+        <p:spPr>
+          <a:xfrm>
+            <a:off x="1389888" y="1965960"/>
+            <a:ext cx="932688" cy="256032"/>
+          </a:xfrm>
+          <a:prstGeom prst="rect">
+            <a:avLst/>
+          </a:prstGeom>
+          <a:noFill/>
+          <a:ln/>
+        </p:spPr>
+        <p:txBody>
+          <a:bodyPr wrap="square" lIns="0" tIns="0" rIns="0" bIns="0" rtlCol="0" anchor="ctr"/>
+          <a:lstStyle/>
+          <a:p>
+            <a:pPr algn="ctr" indent="0" marL="0">
+              <a:buNone/>
+            </a:pPr>
+            <a:r>
+              <a:rPr lang="en-US" sz="700" b="1" dirty="0">
+                <a:solidFill>
+                  <a:srgbClr val="000000"/>
+                </a:solidFill>
+                <a:latin typeface="Arial" pitchFamily="34" charset="0"/>
+                <a:ea typeface="Arial" pitchFamily="34" charset="-122"/>
+                <a:cs typeface="Arial" pitchFamily="34" charset="-120"/>
+              </a:rPr>
+              <a:t>SOLO REIMPR.</a:t>
+            </a:r>
+            <a:endParaRPr lang="en-US" sz="700" dirty="0"/>
+          </a:p>
+        </p:txBody>
+      </p:sp>
+      <p:sp>
+        <p:nvSpPr>
+          <p:cNvPr id="2019" name="Shape 2019"/>
+          <p:cNvSpPr/>
+          <p:nvPr/>
+        </p:nvSpPr>
+        <p:spPr>
+          <a:xfrm>
+            <a:off x="2359152" y="1938528"/>
+            <a:ext cx="1005840" cy="310896"/>
+          </a:xfrm>
+          <a:prstGeom prst="rect">
+            <a:avLst/>
+          </a:prstGeom>
+          <a:solidFill>
+            <a:srgbClr val="ED6C23"/>
+          </a:solidFill>
+          <a:ln/>
+        </p:spPr>
+        <p:txBody>
+          <a:bodyPr/>
+          <a:p/>
+        </p:txBody>
+      </p:sp>
+      <p:sp>
+        <p:nvSpPr>
+          <p:cNvPr id="2020" name="Shape 2020"/>
+          <p:cNvSpPr txBox="1"/>
+          <p:nvPr/>
+        </p:nvSpPr>
+        <p:spPr>
+          <a:xfrm>
+            <a:off x="2395728" y="1965960"/>
+            <a:ext cx="932688" cy="256032"/>
+          </a:xfrm>
+          <a:prstGeom prst="rect">
+            <a:avLst/>
+          </a:prstGeom>
+          <a:noFill/>
+          <a:ln/>
+        </p:spPr>
+        <p:txBody>
+          <a:bodyPr wrap="square" lIns="0" tIns="0" rIns="0" bIns="0" rtlCol="0" anchor="ctr"/>
+          <a:lstStyle/>
+          <a:p>
+            <a:pPr algn="ctr" indent="0" marL="0">
+              <a:buNone/>
+            </a:pPr>
+            <a:r>
+              <a:rPr lang="en-US" sz="700" b="1" dirty="0">
+                <a:solidFill>
+                  <a:srgbClr val="000000"/>
+                </a:solidFill>
+                <a:latin typeface="Arial" pitchFamily="34" charset="0"/>
+                <a:ea typeface="Arial" pitchFamily="34" charset="-122"/>
+                <a:cs typeface="Arial" pitchFamily="34" charset="-120"/>
+              </a:rPr>
+              <a:t>COMPLETO</a:t>
+            </a:r>
+            <a:endParaRPr lang="en-US" sz="700" dirty="0"/>
+          </a:p>
+        </p:txBody>
+      </p:sp>
+      <p:sp>
+        <p:nvSpPr>
+          <p:cNvPr id="2021" name="Shape 2021"/>
+          <p:cNvSpPr/>
+          <p:nvPr/>
+        </p:nvSpPr>
+        <p:spPr>
+          <a:xfrm>
+            <a:off x="3364992" y="1938528"/>
+            <a:ext cx="1188720" cy="310896"/>
+          </a:xfrm>
+          <a:prstGeom prst="rect">
+            <a:avLst/>
+          </a:prstGeom>
+          <a:solidFill>
+            <a:srgbClr val="ED6C23"/>
+          </a:solidFill>
+          <a:ln/>
+        </p:spPr>
+        <p:txBody>
+          <a:bodyPr/>
+          <a:p/>
+        </p:txBody>
+      </p:sp>
+      <p:sp>
+        <p:nvSpPr>
+          <p:cNvPr id="2022" name="Shape 2022"/>
+          <p:cNvSpPr txBox="1"/>
+          <p:nvPr/>
+        </p:nvSpPr>
+        <p:spPr>
+          <a:xfrm>
+            <a:off x="3401568" y="1965960"/>
+            <a:ext cx="1115568" cy="256032"/>
+          </a:xfrm>
+          <a:prstGeom prst="rect">
+            <a:avLst/>
+          </a:prstGeom>
+          <a:noFill/>
+          <a:ln/>
+        </p:spPr>
+        <p:txBody>
+          <a:bodyPr wrap="square" lIns="0" tIns="0" rIns="0" bIns="0" rtlCol="0" anchor="ctr"/>
+          <a:lstStyle/>
+          <a:p>
+            <a:pPr algn="ctr" indent="0" marL="0">
+              <a:buNone/>
+            </a:pPr>
+            <a:r>
+              <a:rPr lang="en-US" sz="700" b="1" dirty="0">
+                <a:solidFill>
+                  <a:srgbClr val="000000"/>
+                </a:solidFill>
+                <a:latin typeface="Arial" pitchFamily="34" charset="0"/>
+                <a:ea typeface="Arial" pitchFamily="34" charset="-122"/>
+                <a:cs typeface="Arial" pitchFamily="34" charset="-120"/>
+              </a:rPr>
+              <a:t>COSTO (CLP)</a:t>
+            </a:r>
+            <a:endParaRPr lang="en-US" sz="700" dirty="0"/>
+          </a:p>
+        </p:txBody>
+      </p:sp>
+      <p:sp>
+        <p:nvSpPr>
+          <p:cNvPr id="2023" name="Shape 2023"/>
+          <p:cNvSpPr/>
+          <p:nvPr/>
+        </p:nvSpPr>
+        <p:spPr>
+          <a:xfrm>
+            <a:off x="164592" y="2286000"/>
+            <a:ext cx="1188720" cy="256032"/>
+          </a:xfrm>
+          <a:prstGeom prst="rect">
+            <a:avLst/>
+          </a:prstGeom>
+          <a:solidFill>
+            <a:srgbClr val="2D2D2D"/>
+          </a:solidFill>
+          <a:ln/>
+        </p:spPr>
+        <p:txBody>
+          <a:bodyPr/>
+          <a:p/>
+        </p:txBody>
+      </p:sp>
+      <p:sp>
+        <p:nvSpPr>
+          <p:cNvPr id="2024" name="Shape 2024"/>
+          <p:cNvSpPr/>
+          <p:nvPr/>
+        </p:nvSpPr>
+        <p:spPr>
+          <a:xfrm>
+            <a:off x="1353312" y="2286000"/>
+            <a:ext cx="1005840" cy="256032"/>
+          </a:xfrm>
+          <a:prstGeom prst="rect">
+            <a:avLst/>
+          </a:prstGeom>
+          <a:solidFill>
+            <a:srgbClr val="2D2D2D"/>
+          </a:solidFill>
+          <a:ln/>
+        </p:spPr>
+        <p:txBody>
+          <a:bodyPr/>
+          <a:p/>
+        </p:txBody>
+      </p:sp>
+      <p:sp>
+        <p:nvSpPr>
+          <p:cNvPr id="2025" name="Shape 2025"/>
+          <p:cNvSpPr/>
+          <p:nvPr/>
+        </p:nvSpPr>
+        <p:spPr>
+          <a:xfrm>
+            <a:off x="2359152" y="2286000"/>
+            <a:ext cx="1005840" cy="256032"/>
+          </a:xfrm>
+          <a:prstGeom prst="rect">
+            <a:avLst/>
+          </a:prstGeom>
+          <a:solidFill>
+            <a:srgbClr val="2D2D2D"/>
+          </a:solidFill>
+          <a:ln/>
+        </p:spPr>
+        <p:txBody>
+          <a:bodyPr/>
+          <a:p/>
+        </p:txBody>
+      </p:sp>
+      <p:sp>
+        <p:nvSpPr>
+          <p:cNvPr id="2026" name="Shape 2026"/>
+          <p:cNvSpPr/>
+          <p:nvPr/>
+        </p:nvSpPr>
+        <p:spPr>
+          <a:xfrm>
+            <a:off x="3364992" y="2286000"/>
+            <a:ext cx="1188720" cy="256032"/>
+          </a:xfrm>
+          <a:prstGeom prst="rect">
+            <a:avLst/>
+          </a:prstGeom>
+          <a:solidFill>
+            <a:srgbClr val="2D2D2D"/>
+          </a:solidFill>
+          <a:ln/>
+        </p:spPr>
+        <p:txBody>
+          <a:bodyPr/>
+          <a:p/>
+        </p:txBody>
+      </p:sp>
+      <p:sp>
+        <p:nvSpPr>
+          <p:cNvPr id="2027" name="Shape 2027"/>
+          <p:cNvSpPr txBox="1"/>
+          <p:nvPr/>
+        </p:nvSpPr>
+        <p:spPr>
+          <a:xfrm>
+            <a:off x="192024" y="2313432"/>
+            <a:ext cx="1133856" cy="201168"/>
+          </a:xfrm>
+          <a:prstGeom prst="rect">
+            <a:avLst/>
+          </a:prstGeom>
+          <a:noFill/>
+          <a:ln/>
+        </p:spPr>
+        <p:txBody>
+          <a:bodyPr wrap="square" lIns="0" tIns="0" rIns="0" bIns="0" rtlCol="0" anchor="ctr"/>
+          <a:lstStyle/>
+          <a:p>
+            <a:pPr algn="l" indent="0" marL="0">
+              <a:buNone/>
+            </a:pPr>
+            <a:r>
+              <a:rPr lang="en-US" sz="750" b="1" dirty="0">
+                <a:solidFill>
+                  <a:srgbClr val="FFFFFF"/>
+                </a:solidFill>
+                <a:latin typeface="Arial" pitchFamily="34" charset="0"/>
+                <a:ea typeface="Arial" pitchFamily="34" charset="-122"/>
+                <a:cs typeface="Arial" pitchFamily="34" charset="-120"/>
+              </a:rPr>
+              <a:t>MAYO</a:t>
+            </a:r>
+            <a:endParaRPr lang="en-US" sz="750" dirty="0"/>
+          </a:p>
+        </p:txBody>
+      </p:sp>
+      <p:sp>
+        <p:nvSpPr>
+          <p:cNvPr id="2028" name="Shape 2028"/>
+          <p:cNvSpPr txBox="1"/>
+          <p:nvPr/>
+        </p:nvSpPr>
+        <p:spPr>
+          <a:xfrm>
+            <a:off x="1380744" y="2313432"/>
+            <a:ext cx="950976" cy="201168"/>
+          </a:xfrm>
+          <a:prstGeom prst="rect">
+            <a:avLst/>
+          </a:prstGeom>
+          <a:noFill/>
+          <a:ln/>
+        </p:spPr>
+        <p:txBody>
+          <a:bodyPr wrap="square" lIns="0" tIns="0" rIns="0" bIns="0" rtlCol="0" anchor="ctr"/>
+          <a:lstStyle/>
+          <a:p>
+            <a:pPr algn="ctr" indent="0" marL="0">
+              <a:buNone/>
+            </a:pPr>
+            <a:r>
+              <a:rPr lang="en-US" sz="750" dirty="0">
+                <a:solidFill>
+                  <a:srgbClr val="27AE60"/>
+                </a:solidFill>
+                <a:latin typeface="Arial" pitchFamily="34" charset="0"/>
+                <a:ea typeface="Arial" pitchFamily="34" charset="-122"/>
+                <a:cs typeface="Arial" pitchFamily="34" charset="-120"/>
+              </a:rPr>
+              <a:t>12 m</a:t>
+            </a:r>
+            <a:endParaRPr lang="en-US" sz="750" dirty="0"/>
+          </a:p>
+        </p:txBody>
+      </p:sp>
+      <p:sp>
+        <p:nvSpPr>
+          <p:cNvPr id="2029" name="Shape 2029"/>
+          <p:cNvSpPr txBox="1"/>
+          <p:nvPr/>
+        </p:nvSpPr>
+        <p:spPr>
+          <a:xfrm>
+            <a:off x="2386584" y="2313432"/>
+            <a:ext cx="950976" cy="201168"/>
+          </a:xfrm>
+          <a:prstGeom prst="rect">
+            <a:avLst/>
+          </a:prstGeom>
+          <a:noFill/>
+          <a:ln/>
+        </p:spPr>
+        <p:txBody>
+          <a:bodyPr wrap="square" lIns="0" tIns="0" rIns="0" bIns="0" rtlCol="0" anchor="ctr"/>
+          <a:lstStyle/>
+          <a:p>
+            <a:pPr algn="ctr" indent="0" marL="0">
+              <a:buNone/>
+            </a:pPr>
+            <a:r>
+              <a:rPr lang="en-US" sz="750" dirty="0">
+                <a:solidFill>
+                  <a:srgbClr val="FFFFFF"/>
+                </a:solidFill>
+                <a:latin typeface="Arial" pitchFamily="34" charset="0"/>
+                <a:ea typeface="Arial" pitchFamily="34" charset="-122"/>
+                <a:cs typeface="Arial" pitchFamily="34" charset="-120"/>
+              </a:rPr>
+              <a:t>121 m</a:t>
+            </a:r>
+            <a:endParaRPr lang="en-US" sz="750" dirty="0"/>
+          </a:p>
+        </p:txBody>
+      </p:sp>
+      <p:sp>
+        <p:nvSpPr>
+          <p:cNvPr id="2030" name="Shape 2030"/>
+          <p:cNvSpPr txBox="1"/>
+          <p:nvPr/>
+        </p:nvSpPr>
+        <p:spPr>
+          <a:xfrm>
+            <a:off x="3392424" y="2313432"/>
+            <a:ext cx="1133856" cy="201168"/>
+          </a:xfrm>
+          <a:prstGeom prst="rect">
+            <a:avLst/>
+          </a:prstGeom>
+          <a:noFill/>
+          <a:ln/>
+        </p:spPr>
+        <p:txBody>
+          <a:bodyPr wrap="square" lIns="0" tIns="0" rIns="0" bIns="0" rtlCol="0" anchor="ctr"/>
+          <a:lstStyle/>
+          <a:p>
+            <a:pPr algn="ctr" indent="0" marL="0">
+              <a:buNone/>
+            </a:pPr>
+            <a:r>
+              <a:rPr lang="en-US" sz="750" dirty="0">
+                <a:solidFill>
+                  <a:srgbClr val="ED6C23"/>
+                </a:solidFill>
+                <a:latin typeface="Arial" pitchFamily="34" charset="0"/>
+                <a:ea typeface="Arial" pitchFamily="34" charset="-122"/>
+                <a:cs typeface="Arial" pitchFamily="34" charset="-120"/>
+              </a:rPr>
+              <a:t>$754.980</a:t>
+            </a:r>
+            <a:endParaRPr lang="en-US" sz="750" dirty="0"/>
+          </a:p>
+        </p:txBody>
+      </p:sp>
+      <p:sp>
+        <p:nvSpPr>
+          <p:cNvPr id="2031" name="Shape 2031"/>
+          <p:cNvSpPr/>
+          <p:nvPr/>
+        </p:nvSpPr>
+        <p:spPr>
+          <a:xfrm>
+            <a:off x="164592" y="2546604"/>
+            <a:ext cx="1188720" cy="256032"/>
+          </a:xfrm>
+          <a:prstGeom prst="rect">
+            <a:avLst/>
+          </a:prstGeom>
+          <a:solidFill>
+            <a:srgbClr val="1E1E1E"/>
+          </a:solidFill>
+          <a:ln/>
+        </p:spPr>
+        <p:txBody>
+          <a:bodyPr/>
+          <a:p/>
+        </p:txBody>
+      </p:sp>
+      <p:sp>
+        <p:nvSpPr>
+          <p:cNvPr id="2032" name="Shape 2032"/>
+          <p:cNvSpPr/>
+          <p:nvPr/>
+        </p:nvSpPr>
+        <p:spPr>
+          <a:xfrm>
+            <a:off x="1353312" y="2546604"/>
+            <a:ext cx="1005840" cy="256032"/>
+          </a:xfrm>
+          <a:prstGeom prst="rect">
+            <a:avLst/>
+          </a:prstGeom>
+          <a:solidFill>
+            <a:srgbClr val="1E1E1E"/>
+          </a:solidFill>
+          <a:ln/>
+        </p:spPr>
+        <p:txBody>
+          <a:bodyPr/>
+          <a:p/>
+        </p:txBody>
+      </p:sp>
+      <p:sp>
+        <p:nvSpPr>
+          <p:cNvPr id="2033" name="Shape 2033"/>
+          <p:cNvSpPr/>
+          <p:nvPr/>
+        </p:nvSpPr>
+        <p:spPr>
+          <a:xfrm>
+            <a:off x="2359152" y="2546604"/>
+            <a:ext cx="1005840" cy="256032"/>
+          </a:xfrm>
+          <a:prstGeom prst="rect">
+            <a:avLst/>
+          </a:prstGeom>
+          <a:solidFill>
+            <a:srgbClr val="1E1E1E"/>
+          </a:solidFill>
+          <a:ln/>
+        </p:spPr>
+        <p:txBody>
+          <a:bodyPr/>
+          <a:p/>
+        </p:txBody>
+      </p:sp>
+      <p:sp>
+        <p:nvSpPr>
+          <p:cNvPr id="2034" name="Shape 2034"/>
+          <p:cNvSpPr/>
+          <p:nvPr/>
+        </p:nvSpPr>
+        <p:spPr>
+          <a:xfrm>
+            <a:off x="3364992" y="2546604"/>
+            <a:ext cx="1188720" cy="256032"/>
+          </a:xfrm>
+          <a:prstGeom prst="rect">
+            <a:avLst/>
+          </a:prstGeom>
+          <a:solidFill>
+            <a:srgbClr val="1E1E1E"/>
+          </a:solidFill>
+          <a:ln/>
+        </p:spPr>
+        <p:txBody>
+          <a:bodyPr/>
+          <a:p/>
+        </p:txBody>
+      </p:sp>
+      <p:sp>
+        <p:nvSpPr>
+          <p:cNvPr id="2035" name="Shape 2035"/>
+          <p:cNvSpPr txBox="1"/>
+          <p:nvPr/>
+        </p:nvSpPr>
+        <p:spPr>
+          <a:xfrm>
+            <a:off x="192024" y="2574036"/>
+            <a:ext cx="1133856" cy="201168"/>
+          </a:xfrm>
+          <a:prstGeom prst="rect">
+            <a:avLst/>
+          </a:prstGeom>
+          <a:noFill/>
+          <a:ln/>
+        </p:spPr>
+        <p:txBody>
+          <a:bodyPr wrap="square" lIns="0" tIns="0" rIns="0" bIns="0" rtlCol="0" anchor="ctr"/>
+          <a:lstStyle/>
+          <a:p>
+            <a:pPr algn="l" indent="0" marL="0">
+              <a:buNone/>
+            </a:pPr>
+            <a:r>
+              <a:rPr lang="en-US" sz="750" b="1" dirty="0">
+                <a:solidFill>
+                  <a:srgbClr val="FFFFFF"/>
+                </a:solidFill>
+                <a:latin typeface="Arial" pitchFamily="34" charset="0"/>
+                <a:ea typeface="Arial" pitchFamily="34" charset="-122"/>
+                <a:cs typeface="Arial" pitchFamily="34" charset="-120"/>
+              </a:rPr>
+              <a:t>JUNIO</a:t>
+            </a:r>
+            <a:endParaRPr lang="en-US" sz="750" dirty="0"/>
+          </a:p>
+        </p:txBody>
+      </p:sp>
+      <p:sp>
+        <p:nvSpPr>
+          <p:cNvPr id="2036" name="Shape 2036"/>
+          <p:cNvSpPr txBox="1"/>
+          <p:nvPr/>
+        </p:nvSpPr>
+        <p:spPr>
+          <a:xfrm>
+            <a:off x="1380744" y="2574036"/>
+            <a:ext cx="950976" cy="201168"/>
+          </a:xfrm>
+          <a:prstGeom prst="rect">
+            <a:avLst/>
+          </a:prstGeom>
+          <a:noFill/>
+          <a:ln/>
+        </p:spPr>
+        <p:txBody>
+          <a:bodyPr wrap="square" lIns="0" tIns="0" rIns="0" bIns="0" rtlCol="0" anchor="ctr"/>
+          <a:lstStyle/>
+          <a:p>
+            <a:pPr algn="ctr" indent="0" marL="0">
+              <a:buNone/>
+            </a:pPr>
+            <a:r>
+              <a:rPr lang="en-US" sz="750" dirty="0">
+                <a:solidFill>
+                  <a:srgbClr val="27AE60"/>
+                </a:solidFill>
+                <a:latin typeface="Arial" pitchFamily="34" charset="0"/>
+                <a:ea typeface="Arial" pitchFamily="34" charset="-122"/>
+                <a:cs typeface="Arial" pitchFamily="34" charset="-120"/>
+              </a:rPr>
+              <a:t>9 m</a:t>
+            </a:r>
+            <a:endParaRPr lang="en-US" sz="750" dirty="0"/>
+          </a:p>
+        </p:txBody>
+      </p:sp>
+      <p:sp>
+        <p:nvSpPr>
+          <p:cNvPr id="2037" name="Shape 2037"/>
+          <p:cNvSpPr txBox="1"/>
+          <p:nvPr/>
+        </p:nvSpPr>
+        <p:spPr>
+          <a:xfrm>
+            <a:off x="2386584" y="2574036"/>
+            <a:ext cx="950976" cy="201168"/>
+          </a:xfrm>
+          <a:prstGeom prst="rect">
+            <a:avLst/>
+          </a:prstGeom>
+          <a:noFill/>
+          <a:ln/>
+        </p:spPr>
+        <p:txBody>
+          <a:bodyPr wrap="square" lIns="0" tIns="0" rIns="0" bIns="0" rtlCol="0" anchor="ctr"/>
+          <a:lstStyle/>
+          <a:p>
+            <a:pPr algn="ctr" indent="0" marL="0">
+              <a:buNone/>
+            </a:pPr>
+            <a:r>
+              <a:rPr lang="en-US" sz="750" dirty="0">
+                <a:solidFill>
+                  <a:srgbClr val="FFFFFF"/>
+                </a:solidFill>
+                <a:latin typeface="Arial" pitchFamily="34" charset="0"/>
+                <a:ea typeface="Arial" pitchFamily="34" charset="-122"/>
+                <a:cs typeface="Arial" pitchFamily="34" charset="-120"/>
+              </a:rPr>
+              <a:t>140 m</a:t>
+            </a:r>
+            <a:endParaRPr lang="en-US" sz="750" dirty="0"/>
+          </a:p>
+        </p:txBody>
+      </p:sp>
+      <p:sp>
+        <p:nvSpPr>
+          <p:cNvPr id="2038" name="Shape 2038"/>
+          <p:cNvSpPr txBox="1"/>
+          <p:nvPr/>
+        </p:nvSpPr>
+        <p:spPr>
+          <a:xfrm>
+            <a:off x="3392424" y="2574036"/>
+            <a:ext cx="1133856" cy="201168"/>
+          </a:xfrm>
+          <a:prstGeom prst="rect">
+            <a:avLst/>
+          </a:prstGeom>
+          <a:noFill/>
+          <a:ln/>
+        </p:spPr>
+        <p:txBody>
+          <a:bodyPr wrap="square" lIns="0" tIns="0" rIns="0" bIns="0" rtlCol="0" anchor="ctr"/>
+          <a:lstStyle/>
+          <a:p>
+            <a:pPr algn="ctr" indent="0" marL="0">
+              <a:buNone/>
+            </a:pPr>
+            <a:r>
+              <a:rPr lang="en-US" sz="750" dirty="0">
+                <a:solidFill>
+                  <a:srgbClr val="ED6C23"/>
+                </a:solidFill>
+                <a:latin typeface="Arial" pitchFamily="34" charset="0"/>
+                <a:ea typeface="Arial" pitchFamily="34" charset="-122"/>
+                <a:cs typeface="Arial" pitchFamily="34" charset="-120"/>
+              </a:rPr>
+              <a:t>$861.120</a:t>
+            </a:r>
+            <a:endParaRPr lang="en-US" sz="750" dirty="0"/>
+          </a:p>
+        </p:txBody>
+      </p:sp>
+      <p:sp>
+        <p:nvSpPr>
+          <p:cNvPr id="2039" name="Shape 2039"/>
+          <p:cNvSpPr/>
+          <p:nvPr/>
+        </p:nvSpPr>
+        <p:spPr>
+          <a:xfrm>
+            <a:off x="164592" y="2807208"/>
+            <a:ext cx="1188720" cy="256032"/>
+          </a:xfrm>
+          <a:prstGeom prst="rect">
+            <a:avLst/>
+          </a:prstGeom>
+          <a:solidFill>
+            <a:srgbClr val="2D2D2D"/>
+          </a:solidFill>
+          <a:ln/>
+        </p:spPr>
+        <p:txBody>
+          <a:bodyPr/>
+          <a:p/>
+        </p:txBody>
+      </p:sp>
+      <p:sp>
+        <p:nvSpPr>
+          <p:cNvPr id="2040" name="Shape 2040"/>
+          <p:cNvSpPr/>
+          <p:nvPr/>
+        </p:nvSpPr>
+        <p:spPr>
+          <a:xfrm>
+            <a:off x="1353312" y="2807208"/>
+            <a:ext cx="1005840" cy="256032"/>
+          </a:xfrm>
+          <a:prstGeom prst="rect">
+            <a:avLst/>
+          </a:prstGeom>
+          <a:solidFill>
+            <a:srgbClr val="2D2D2D"/>
+          </a:solidFill>
+          <a:ln/>
+        </p:spPr>
+        <p:txBody>
+          <a:bodyPr/>
+          <a:p/>
+        </p:txBody>
+      </p:sp>
+      <p:sp>
+        <p:nvSpPr>
+          <p:cNvPr id="2041" name="Shape 2041"/>
+          <p:cNvSpPr/>
+          <p:nvPr/>
+        </p:nvSpPr>
+        <p:spPr>
+          <a:xfrm>
+            <a:off x="2359152" y="2807208"/>
+            <a:ext cx="1005840" cy="256032"/>
+          </a:xfrm>
+          <a:prstGeom prst="rect">
+            <a:avLst/>
+          </a:prstGeom>
+          <a:solidFill>
+            <a:srgbClr val="2D2D2D"/>
+          </a:solidFill>
+          <a:ln/>
+        </p:spPr>
+        <p:txBody>
+          <a:bodyPr/>
+          <a:p/>
+        </p:txBody>
+      </p:sp>
+      <p:sp>
+        <p:nvSpPr>
+          <p:cNvPr id="2042" name="Shape 2042"/>
+          <p:cNvSpPr/>
+          <p:nvPr/>
+        </p:nvSpPr>
+        <p:spPr>
+          <a:xfrm>
+            <a:off x="3364992" y="2807208"/>
+            <a:ext cx="1188720" cy="256032"/>
+          </a:xfrm>
+          <a:prstGeom prst="rect">
+            <a:avLst/>
+          </a:prstGeom>
+          <a:solidFill>
+            <a:srgbClr val="2D2D2D"/>
+          </a:solidFill>
+          <a:ln/>
+        </p:spPr>
+        <p:txBody>
+          <a:bodyPr/>
+          <a:p/>
+        </p:txBody>
+      </p:sp>
+      <p:sp>
+        <p:nvSpPr>
+          <p:cNvPr id="2043" name="Shape 2043"/>
+          <p:cNvSpPr txBox="1"/>
+          <p:nvPr/>
+        </p:nvSpPr>
+        <p:spPr>
+          <a:xfrm>
+            <a:off x="192024" y="2834640"/>
+            <a:ext cx="1133856" cy="201168"/>
+          </a:xfrm>
+          <a:prstGeom prst="rect">
+            <a:avLst/>
+          </a:prstGeom>
+          <a:noFill/>
+          <a:ln/>
+        </p:spPr>
+        <p:txBody>
+          <a:bodyPr wrap="square" lIns="0" tIns="0" rIns="0" bIns="0" rtlCol="0" anchor="ctr"/>
+          <a:lstStyle/>
+          <a:p>
+            <a:pPr algn="l" indent="0" marL="0">
+              <a:buNone/>
+            </a:pPr>
+            <a:r>
+              <a:rPr lang="en-US" sz="750" b="1" dirty="0">
+                <a:solidFill>
+                  <a:srgbClr val="FFFFFF"/>
+                </a:solidFill>
+                <a:latin typeface="Arial" pitchFamily="34" charset="0"/>
+                <a:ea typeface="Arial" pitchFamily="34" charset="-122"/>
+                <a:cs typeface="Arial" pitchFamily="34" charset="-120"/>
+              </a:rPr>
+              <a:t>JULIO*</a:t>
+            </a:r>
+            <a:endParaRPr lang="en-US" sz="750" dirty="0"/>
+          </a:p>
+        </p:txBody>
+      </p:sp>
+      <p:sp>
+        <p:nvSpPr>
+          <p:cNvPr id="2044" name="Shape 2044"/>
+          <p:cNvSpPr txBox="1"/>
+          <p:nvPr/>
+        </p:nvSpPr>
+        <p:spPr>
+          <a:xfrm>
+            <a:off x="1380744" y="2834640"/>
+            <a:ext cx="950976" cy="201168"/>
+          </a:xfrm>
+          <a:prstGeom prst="rect">
+            <a:avLst/>
+          </a:prstGeom>
+          <a:noFill/>
+          <a:ln/>
+        </p:spPr>
+        <p:txBody>
+          <a:bodyPr wrap="square" lIns="0" tIns="0" rIns="0" bIns="0" rtlCol="0" anchor="ctr"/>
+          <a:lstStyle/>
+          <a:p>
+            <a:pPr algn="ctr" indent="0" marL="0">
+              <a:buNone/>
+            </a:pPr>
+            <a:r>
+              <a:rPr lang="en-US" sz="750" dirty="0">
+                <a:solidFill>
+                  <a:srgbClr val="27AE60"/>
+                </a:solidFill>
+                <a:latin typeface="Arial" pitchFamily="34" charset="0"/>
+                <a:ea typeface="Arial" pitchFamily="34" charset="-122"/>
+                <a:cs typeface="Arial" pitchFamily="34" charset="-120"/>
+              </a:rPr>
+              <a:t>13 m</a:t>
+            </a:r>
+            <a:endParaRPr lang="en-US" sz="750" dirty="0"/>
+          </a:p>
+        </p:txBody>
+      </p:sp>
+      <p:sp>
+        <p:nvSpPr>
+          <p:cNvPr id="2045" name="Shape 2045"/>
+          <p:cNvSpPr txBox="1"/>
+          <p:nvPr/>
+        </p:nvSpPr>
+        <p:spPr>
+          <a:xfrm>
+            <a:off x="2386584" y="2834640"/>
+            <a:ext cx="950976" cy="201168"/>
+          </a:xfrm>
+          <a:prstGeom prst="rect">
+            <a:avLst/>
+          </a:prstGeom>
+          <a:noFill/>
+          <a:ln/>
+        </p:spPr>
+        <p:txBody>
+          <a:bodyPr wrap="square" lIns="0" tIns="0" rIns="0" bIns="0" rtlCol="0" anchor="ctr"/>
+          <a:lstStyle/>
+          <a:p>
+            <a:pPr algn="ctr" indent="0" marL="0">
+              <a:buNone/>
+            </a:pPr>
+            <a:r>
+              <a:rPr lang="en-US" sz="750" dirty="0">
+                <a:solidFill>
+                  <a:srgbClr val="FFFFFF"/>
+                </a:solidFill>
+                <a:latin typeface="Arial" pitchFamily="34" charset="0"/>
+                <a:ea typeface="Arial" pitchFamily="34" charset="-122"/>
+                <a:cs typeface="Arial" pitchFamily="34" charset="-120"/>
+              </a:rPr>
+              <a:t>232 m</a:t>
+            </a:r>
+            <a:endParaRPr lang="en-US" sz="750" dirty="0"/>
+          </a:p>
+        </p:txBody>
+      </p:sp>
+      <p:sp>
+        <p:nvSpPr>
+          <p:cNvPr id="2046" name="Shape 2046"/>
+          <p:cNvSpPr txBox="1"/>
+          <p:nvPr/>
+        </p:nvSpPr>
+        <p:spPr>
+          <a:xfrm>
+            <a:off x="3392424" y="2834640"/>
+            <a:ext cx="1133856" cy="201168"/>
+          </a:xfrm>
+          <a:prstGeom prst="rect">
+            <a:avLst/>
+          </a:prstGeom>
+          <a:noFill/>
+          <a:ln/>
+        </p:spPr>
+        <p:txBody>
+          <a:bodyPr wrap="square" lIns="0" tIns="0" rIns="0" bIns="0" rtlCol="0" anchor="ctr"/>
+          <a:lstStyle/>
+          <a:p>
+            <a:pPr algn="ctr" indent="0" marL="0">
+              <a:buNone/>
+            </a:pPr>
+            <a:r>
+              <a:rPr lang="en-US" sz="750" dirty="0">
+                <a:solidFill>
+                  <a:srgbClr val="ED6C23"/>
+                </a:solidFill>
+                <a:latin typeface="Arial" pitchFamily="34" charset="0"/>
+                <a:ea typeface="Arial" pitchFamily="34" charset="-122"/>
+                <a:cs typeface="Arial" pitchFamily="34" charset="-120"/>
+              </a:rPr>
+              <a:t>$1.422.372</a:t>
+            </a:r>
+            <a:endParaRPr lang="en-US" sz="750" dirty="0"/>
+          </a:p>
+        </p:txBody>
+      </p:sp>
+      <p:sp>
+        <p:nvSpPr>
+          <p:cNvPr id="2047" name="Shape 2047"/>
+          <p:cNvSpPr/>
+          <p:nvPr/>
+        </p:nvSpPr>
+        <p:spPr>
+          <a:xfrm>
+            <a:off x="164592" y="3067812"/>
+            <a:ext cx="1188720" cy="256032"/>
+          </a:xfrm>
+          <a:prstGeom prst="rect">
+            <a:avLst/>
+          </a:prstGeom>
+          <a:solidFill>
+            <a:srgbClr val="1E1E1E"/>
+          </a:solidFill>
+          <a:ln/>
+        </p:spPr>
+        <p:txBody>
+          <a:bodyPr/>
+          <a:p/>
+        </p:txBody>
+      </p:sp>
+      <p:sp>
+        <p:nvSpPr>
+          <p:cNvPr id="2048" name="Shape 2048"/>
+          <p:cNvSpPr/>
+          <p:nvPr/>
+        </p:nvSpPr>
+        <p:spPr>
+          <a:xfrm>
+            <a:off x="1353312" y="3067812"/>
+            <a:ext cx="1005840" cy="256032"/>
+          </a:xfrm>
+          <a:prstGeom prst="rect">
+            <a:avLst/>
+          </a:prstGeom>
+          <a:solidFill>
+            <a:srgbClr val="1E1E1E"/>
+          </a:solidFill>
+          <a:ln/>
+        </p:spPr>
+        <p:txBody>
+          <a:bodyPr/>
+          <a:p/>
+        </p:txBody>
+      </p:sp>
+      <p:sp>
+        <p:nvSpPr>
+          <p:cNvPr id="2049" name="Shape 2049"/>
+          <p:cNvSpPr/>
+          <p:nvPr/>
+        </p:nvSpPr>
+        <p:spPr>
+          <a:xfrm>
+            <a:off x="2359152" y="3067812"/>
+            <a:ext cx="1005840" cy="256032"/>
+          </a:xfrm>
+          <a:prstGeom prst="rect">
+            <a:avLst/>
+          </a:prstGeom>
+          <a:solidFill>
+            <a:srgbClr val="1E1E1E"/>
+          </a:solidFill>
+          <a:ln/>
+        </p:spPr>
+        <p:txBody>
+          <a:bodyPr/>
+          <a:p/>
+        </p:txBody>
+      </p:sp>
+      <p:sp>
+        <p:nvSpPr>
+          <p:cNvPr id="2050" name="Shape 2050"/>
+          <p:cNvSpPr/>
+          <p:nvPr/>
+        </p:nvSpPr>
+        <p:spPr>
+          <a:xfrm>
+            <a:off x="3364992" y="3067812"/>
+            <a:ext cx="1188720" cy="256032"/>
+          </a:xfrm>
+          <a:prstGeom prst="rect">
+            <a:avLst/>
+          </a:prstGeom>
+          <a:solidFill>
+            <a:srgbClr val="1E1E1E"/>
+          </a:solidFill>
+          <a:ln/>
+        </p:spPr>
+        <p:txBody>
+          <a:bodyPr/>
+          <a:p/>
+        </p:txBody>
+      </p:sp>
+      <p:sp>
+        <p:nvSpPr>
+          <p:cNvPr id="2051" name="Shape 2051"/>
+          <p:cNvSpPr txBox="1"/>
+          <p:nvPr/>
+        </p:nvSpPr>
+        <p:spPr>
+          <a:xfrm>
+            <a:off x="192024" y="3095244"/>
+            <a:ext cx="1133856" cy="201168"/>
+          </a:xfrm>
+          <a:prstGeom prst="rect">
+            <a:avLst/>
+          </a:prstGeom>
+          <a:noFill/>
+          <a:ln/>
+        </p:spPr>
+        <p:txBody>
+          <a:bodyPr wrap="square" lIns="0" tIns="0" rIns="0" bIns="0" rtlCol="0" anchor="ctr"/>
+          <a:lstStyle/>
+          <a:p>
+            <a:pPr algn="l" indent="0" marL="0">
+              <a:buNone/>
+            </a:pPr>
+            <a:r>
+              <a:rPr lang="en-US" sz="750" b="1" dirty="0">
+                <a:solidFill>
+                  <a:srgbClr val="FFFFFF"/>
+                </a:solidFill>
+                <a:latin typeface="Arial" pitchFamily="34" charset="0"/>
+                <a:ea typeface="Arial" pitchFamily="34" charset="-122"/>
+                <a:cs typeface="Arial" pitchFamily="34" charset="-120"/>
+              </a:rPr>
+              <a:t>AGOSTO</a:t>
+            </a:r>
+            <a:endParaRPr lang="en-US" sz="750" dirty="0"/>
+          </a:p>
+        </p:txBody>
+      </p:sp>
+      <p:sp>
+        <p:nvSpPr>
+          <p:cNvPr id="2052" name="Shape 2052"/>
+          <p:cNvSpPr txBox="1"/>
+          <p:nvPr/>
+        </p:nvSpPr>
+        <p:spPr>
+          <a:xfrm>
+            <a:off x="1380744" y="3095244"/>
+            <a:ext cx="950976" cy="201168"/>
+          </a:xfrm>
+          <a:prstGeom prst="rect">
+            <a:avLst/>
+          </a:prstGeom>
+          <a:noFill/>
+          <a:ln/>
+        </p:spPr>
+        <p:txBody>
+          <a:bodyPr wrap="square" lIns="0" tIns="0" rIns="0" bIns="0" rtlCol="0" anchor="ctr"/>
+          <a:lstStyle/>
+          <a:p>
+            <a:pPr algn="ctr" indent="0" marL="0">
+              <a:buNone/>
+            </a:pPr>
+            <a:r>
+              <a:rPr lang="en-US" sz="750" dirty="0">
+                <a:solidFill>
+                  <a:srgbClr val="27AE60"/>
+                </a:solidFill>
+                <a:latin typeface="Arial" pitchFamily="34" charset="0"/>
+                <a:ea typeface="Arial" pitchFamily="34" charset="-122"/>
+                <a:cs typeface="Arial" pitchFamily="34" charset="-120"/>
+              </a:rPr>
+              <a:t>10 m</a:t>
+            </a:r>
+            <a:endParaRPr lang="en-US" sz="750" dirty="0"/>
+          </a:p>
+        </p:txBody>
+      </p:sp>
+      <p:sp>
+        <p:nvSpPr>
+          <p:cNvPr id="2053" name="Shape 2053"/>
+          <p:cNvSpPr txBox="1"/>
+          <p:nvPr/>
+        </p:nvSpPr>
+        <p:spPr>
+          <a:xfrm>
+            <a:off x="2386584" y="3095244"/>
+            <a:ext cx="950976" cy="201168"/>
+          </a:xfrm>
+          <a:prstGeom prst="rect">
+            <a:avLst/>
+          </a:prstGeom>
+          <a:noFill/>
+          <a:ln/>
+        </p:spPr>
+        <p:txBody>
+          <a:bodyPr wrap="square" lIns="0" tIns="0" rIns="0" bIns="0" rtlCol="0" anchor="ctr"/>
+          <a:lstStyle/>
+          <a:p>
+            <a:pPr algn="ctr" indent="0" marL="0">
+              <a:buNone/>
+            </a:pPr>
+            <a:r>
+              <a:rPr lang="en-US" sz="750" dirty="0">
+                <a:solidFill>
+                  <a:srgbClr val="FFFFFF"/>
+                </a:solidFill>
+                <a:latin typeface="Arial" pitchFamily="34" charset="0"/>
+                <a:ea typeface="Arial" pitchFamily="34" charset="-122"/>
+                <a:cs typeface="Arial" pitchFamily="34" charset="-120"/>
+              </a:rPr>
+              <a:t>269 m</a:t>
+            </a:r>
+            <a:endParaRPr lang="en-US" sz="750" dirty="0"/>
+          </a:p>
+        </p:txBody>
+      </p:sp>
+      <p:sp>
+        <p:nvSpPr>
+          <p:cNvPr id="2054" name="Shape 2054"/>
+          <p:cNvSpPr txBox="1"/>
+          <p:nvPr/>
+        </p:nvSpPr>
+        <p:spPr>
+          <a:xfrm>
+            <a:off x="3392424" y="3095244"/>
+            <a:ext cx="1133856" cy="201168"/>
+          </a:xfrm>
+          <a:prstGeom prst="rect">
+            <a:avLst/>
+          </a:prstGeom>
+          <a:noFill/>
+          <a:ln/>
+        </p:spPr>
+        <p:txBody>
+          <a:bodyPr wrap="square" lIns="0" tIns="0" rIns="0" bIns="0" rtlCol="0" anchor="ctr"/>
+          <a:lstStyle/>
+          <a:p>
+            <a:pPr algn="ctr" indent="0" marL="0">
+              <a:buNone/>
+            </a:pPr>
+            <a:r>
+              <a:rPr lang="en-US" sz="750" dirty="0">
+                <a:solidFill>
+                  <a:srgbClr val="ED6C23"/>
+                </a:solidFill>
+                <a:latin typeface="Arial" pitchFamily="34" charset="0"/>
+                <a:ea typeface="Arial" pitchFamily="34" charset="-122"/>
+                <a:cs typeface="Arial" pitchFamily="34" charset="-120"/>
+              </a:rPr>
+              <a:t>$1.636.356</a:t>
+            </a:r>
+            <a:endParaRPr lang="en-US" sz="750" dirty="0"/>
+          </a:p>
+        </p:txBody>
+      </p:sp>
+      <p:sp>
+        <p:nvSpPr>
+          <p:cNvPr id="2055" name="Shape 2055"/>
+          <p:cNvSpPr/>
+          <p:nvPr/>
+        </p:nvSpPr>
+        <p:spPr>
+          <a:xfrm>
+            <a:off x="164592" y="3328416"/>
+            <a:ext cx="1188720" cy="256032"/>
+          </a:xfrm>
+          <a:prstGeom prst="rect">
+            <a:avLst/>
+          </a:prstGeom>
+          <a:solidFill>
+            <a:srgbClr val="2D2D2D"/>
+          </a:solidFill>
+          <a:ln/>
+        </p:spPr>
+        <p:txBody>
+          <a:bodyPr/>
+          <a:p/>
+        </p:txBody>
+      </p:sp>
+      <p:sp>
+        <p:nvSpPr>
+          <p:cNvPr id="2056" name="Shape 2056"/>
+          <p:cNvSpPr/>
+          <p:nvPr/>
+        </p:nvSpPr>
+        <p:spPr>
+          <a:xfrm>
+            <a:off x="1353312" y="3328416"/>
+            <a:ext cx="1005840" cy="256032"/>
+          </a:xfrm>
+          <a:prstGeom prst="rect">
+            <a:avLst/>
+          </a:prstGeom>
+          <a:solidFill>
+            <a:srgbClr val="2D2D2D"/>
+          </a:solidFill>
+          <a:ln/>
+        </p:spPr>
+        <p:txBody>
+          <a:bodyPr/>
+          <a:p/>
+        </p:txBody>
+      </p:sp>
+      <p:sp>
+        <p:nvSpPr>
+          <p:cNvPr id="2057" name="Shape 2057"/>
+          <p:cNvSpPr/>
+          <p:nvPr/>
+        </p:nvSpPr>
+        <p:spPr>
+          <a:xfrm>
+            <a:off x="2359152" y="3328416"/>
+            <a:ext cx="1005840" cy="256032"/>
+          </a:xfrm>
+          <a:prstGeom prst="rect">
+            <a:avLst/>
+          </a:prstGeom>
+          <a:solidFill>
+            <a:srgbClr val="2D2D2D"/>
+          </a:solidFill>
+          <a:ln/>
+        </p:spPr>
+        <p:txBody>
+          <a:bodyPr/>
+          <a:p/>
+        </p:txBody>
+      </p:sp>
+      <p:sp>
+        <p:nvSpPr>
+          <p:cNvPr id="2058" name="Shape 2058"/>
+          <p:cNvSpPr/>
+          <p:nvPr/>
+        </p:nvSpPr>
+        <p:spPr>
+          <a:xfrm>
+            <a:off x="3364992" y="3328416"/>
+            <a:ext cx="1188720" cy="256032"/>
+          </a:xfrm>
+          <a:prstGeom prst="rect">
+            <a:avLst/>
+          </a:prstGeom>
+          <a:solidFill>
+            <a:srgbClr val="2D2D2D"/>
+          </a:solidFill>
+          <a:ln/>
+        </p:spPr>
+        <p:txBody>
+          <a:bodyPr/>
+          <a:p/>
+        </p:txBody>
+      </p:sp>
+      <p:sp>
+        <p:nvSpPr>
+          <p:cNvPr id="2059" name="Shape 2059"/>
+          <p:cNvSpPr txBox="1"/>
+          <p:nvPr/>
+        </p:nvSpPr>
+        <p:spPr>
+          <a:xfrm>
+            <a:off x="192024" y="3355848"/>
+            <a:ext cx="1133856" cy="201168"/>
+          </a:xfrm>
+          <a:prstGeom prst="rect">
+            <a:avLst/>
+          </a:prstGeom>
+          <a:noFill/>
+          <a:ln/>
+        </p:spPr>
+        <p:txBody>
+          <a:bodyPr wrap="square" lIns="0" tIns="0" rIns="0" bIns="0" rtlCol="0" anchor="ctr"/>
+          <a:lstStyle/>
+          <a:p>
+            <a:pPr algn="l" indent="0" marL="0">
+              <a:buNone/>
+            </a:pPr>
+            <a:r>
+              <a:rPr lang="en-US" sz="750" b="1" dirty="0">
+                <a:solidFill>
+                  <a:srgbClr val="FFFFFF"/>
+                </a:solidFill>
+                <a:latin typeface="Arial" pitchFamily="34" charset="0"/>
+                <a:ea typeface="Arial" pitchFamily="34" charset="-122"/>
+                <a:cs typeface="Arial" pitchFamily="34" charset="-120"/>
+              </a:rPr>
+              <a:t>SEPTIEMBRE</a:t>
+            </a:r>
+            <a:endParaRPr lang="en-US" sz="750" dirty="0"/>
+          </a:p>
+        </p:txBody>
+      </p:sp>
+      <p:sp>
+        <p:nvSpPr>
+          <p:cNvPr id="2060" name="Shape 2060"/>
+          <p:cNvSpPr txBox="1"/>
+          <p:nvPr/>
+        </p:nvSpPr>
+        <p:spPr>
+          <a:xfrm>
+            <a:off x="1380744" y="3355848"/>
+            <a:ext cx="950976" cy="201168"/>
+          </a:xfrm>
+          <a:prstGeom prst="rect">
+            <a:avLst/>
+          </a:prstGeom>
+          <a:noFill/>
+          <a:ln/>
+        </p:spPr>
+        <p:txBody>
+          <a:bodyPr wrap="square" lIns="0" tIns="0" rIns="0" bIns="0" rtlCol="0" anchor="ctr"/>
+          <a:lstStyle/>
+          <a:p>
+            <a:pPr algn="ctr" indent="0" marL="0">
+              <a:buNone/>
+            </a:pPr>
+            <a:r>
+              <a:rPr lang="en-US" sz="750" dirty="0">
+                <a:solidFill>
+                  <a:srgbClr val="27AE60"/>
+                </a:solidFill>
+                <a:latin typeface="Arial" pitchFamily="34" charset="0"/>
+                <a:ea typeface="Arial" pitchFamily="34" charset="-122"/>
+                <a:cs typeface="Arial" pitchFamily="34" charset="-120"/>
+              </a:rPr>
+              <a:t>6 m</a:t>
+            </a:r>
+            <a:endParaRPr lang="en-US" sz="750" dirty="0"/>
+          </a:p>
+        </p:txBody>
+      </p:sp>
+      <p:sp>
+        <p:nvSpPr>
+          <p:cNvPr id="2061" name="Shape 2061"/>
+          <p:cNvSpPr txBox="1"/>
+          <p:nvPr/>
+        </p:nvSpPr>
+        <p:spPr>
+          <a:xfrm>
+            <a:off x="2386584" y="3355848"/>
+            <a:ext cx="950976" cy="201168"/>
+          </a:xfrm>
+          <a:prstGeom prst="rect">
+            <a:avLst/>
+          </a:prstGeom>
+          <a:noFill/>
+          <a:ln/>
+        </p:spPr>
+        <p:txBody>
+          <a:bodyPr wrap="square" lIns="0" tIns="0" rIns="0" bIns="0" rtlCol="0" anchor="ctr"/>
+          <a:lstStyle/>
+          <a:p>
+            <a:pPr algn="ctr" indent="0" marL="0">
+              <a:buNone/>
+            </a:pPr>
+            <a:r>
+              <a:rPr lang="en-US" sz="750" dirty="0">
+                <a:solidFill>
+                  <a:srgbClr val="FFFFFF"/>
+                </a:solidFill>
+                <a:latin typeface="Arial" pitchFamily="34" charset="0"/>
+                <a:ea typeface="Arial" pitchFamily="34" charset="-122"/>
+                <a:cs typeface="Arial" pitchFamily="34" charset="-120"/>
+              </a:rPr>
+              <a:t>121 m</a:t>
+            </a:r>
+            <a:endParaRPr lang="en-US" sz="750" dirty="0"/>
+          </a:p>
+        </p:txBody>
+      </p:sp>
+      <p:sp>
+        <p:nvSpPr>
+          <p:cNvPr id="2062" name="Shape 2062"/>
+          <p:cNvSpPr txBox="1"/>
+          <p:nvPr/>
+        </p:nvSpPr>
+        <p:spPr>
+          <a:xfrm>
+            <a:off x="3392424" y="3355848"/>
+            <a:ext cx="1133856" cy="201168"/>
+          </a:xfrm>
+          <a:prstGeom prst="rect">
+            <a:avLst/>
+          </a:prstGeom>
+          <a:noFill/>
+          <a:ln/>
+        </p:spPr>
+        <p:txBody>
+          <a:bodyPr wrap="square" lIns="0" tIns="0" rIns="0" bIns="0" rtlCol="0" anchor="ctr"/>
+          <a:lstStyle/>
+          <a:p>
+            <a:pPr algn="ctr" indent="0" marL="0">
+              <a:buNone/>
+            </a:pPr>
+            <a:r>
+              <a:rPr lang="en-US" sz="750" dirty="0">
+                <a:solidFill>
+                  <a:srgbClr val="ED6C23"/>
+                </a:solidFill>
+                <a:latin typeface="Arial" pitchFamily="34" charset="0"/>
+                <a:ea typeface="Arial" pitchFamily="34" charset="-122"/>
+                <a:cs typeface="Arial" pitchFamily="34" charset="-120"/>
+              </a:rPr>
+              <a:t>$741.504</a:t>
+            </a:r>
+            <a:endParaRPr lang="en-US" sz="750" dirty="0"/>
+          </a:p>
+        </p:txBody>
+      </p:sp>
+      <p:sp>
+        <p:nvSpPr>
+          <p:cNvPr id="2063" name="Shape 2063"/>
+          <p:cNvSpPr/>
+          <p:nvPr/>
+        </p:nvSpPr>
+        <p:spPr>
+          <a:xfrm>
+            <a:off x="164592" y="3589020"/>
+            <a:ext cx="1188720" cy="256032"/>
+          </a:xfrm>
+          <a:prstGeom prst="rect">
+            <a:avLst/>
+          </a:prstGeom>
+          <a:solidFill>
+            <a:srgbClr val="ED6C23"/>
+          </a:solidFill>
+          <a:ln/>
+        </p:spPr>
+      </p:sp>
+      <p:sp>
+        <p:nvSpPr>
+          <p:cNvPr id="2064" name="Shape 2064"/>
+          <p:cNvSpPr/>
+          <p:nvPr/>
+        </p:nvSpPr>
+        <p:spPr>
+          <a:xfrm>
+            <a:off x="1353312" y="3589020"/>
+            <a:ext cx="1005840" cy="256032"/>
+          </a:xfrm>
+          <a:prstGeom prst="rect">
+            <a:avLst/>
+          </a:prstGeom>
+          <a:solidFill>
+            <a:srgbClr val="ED6C23"/>
+          </a:solidFill>
+          <a:ln/>
+        </p:spPr>
+      </p:sp>
+      <p:sp>
+        <p:nvSpPr>
+          <p:cNvPr id="2065" name="Shape 2065"/>
+          <p:cNvSpPr/>
+          <p:nvPr/>
+        </p:nvSpPr>
+        <p:spPr>
+          <a:xfrm>
+            <a:off x="2359152" y="3589020"/>
+            <a:ext cx="1005840" cy="256032"/>
+          </a:xfrm>
+          <a:prstGeom prst="rect">
+            <a:avLst/>
+          </a:prstGeom>
+          <a:solidFill>
+            <a:srgbClr val="ED6C23"/>
+          </a:solidFill>
+          <a:ln/>
+        </p:spPr>
+      </p:sp>
+      <p:sp>
+        <p:nvSpPr>
+          <p:cNvPr id="2066" name="Shape 2066"/>
+          <p:cNvSpPr/>
+          <p:nvPr/>
+        </p:nvSpPr>
+        <p:spPr>
+          <a:xfrm>
+            <a:off x="3364992" y="3589020"/>
+            <a:ext cx="1188720" cy="256032"/>
+          </a:xfrm>
+          <a:prstGeom prst="rect">
+            <a:avLst/>
+          </a:prstGeom>
+          <a:solidFill>
+            <a:srgbClr val="ED6C23"/>
+          </a:solidFill>
+          <a:ln/>
+        </p:spPr>
+      </p:sp>
+      <p:sp>
+        <p:nvSpPr>
+          <p:cNvPr id="2067" name="Shape 2067"/>
+          <p:cNvSpPr txBox="1"/>
+          <p:nvPr/>
+        </p:nvSpPr>
+        <p:spPr>
+          <a:xfrm>
+            <a:off x="192024" y="3616452"/>
+            <a:ext cx="1133856" cy="201168"/>
+          </a:xfrm>
+          <a:prstGeom prst="rect">
+            <a:avLst/>
+          </a:prstGeom>
+          <a:noFill/>
+          <a:ln/>
+        </p:spPr>
+        <p:txBody>
+          <a:bodyPr wrap="square" lIns="0" tIns="0" rIns="0" bIns="0" rtlCol="0" anchor="ctr"/>
+          <a:lstStyle/>
+          <a:p>
+            <a:pPr algn="l" indent="0" marL="0">
+              <a:buNone/>
+            </a:pPr>
+            <a:r>
+              <a:rPr lang="en-US" sz="750" b="1" dirty="0">
+                <a:solidFill>
+                  <a:srgbClr val="000000"/>
+                </a:solidFill>
+                <a:latin typeface="Arial" pitchFamily="34" charset="0"/>
+                <a:ea typeface="Arial" pitchFamily="34" charset="-122"/>
+                <a:cs typeface="Arial" pitchFamily="34" charset="-120"/>
+              </a:rPr>
+              <a:t>TOTAL</a:t>
+            </a:r>
+            <a:endParaRPr lang="en-US" sz="750" dirty="0"/>
+          </a:p>
+        </p:txBody>
+      </p:sp>
+      <p:sp>
+        <p:nvSpPr>
+          <p:cNvPr id="2068" name="Shape 2068"/>
+          <p:cNvSpPr txBox="1"/>
+          <p:nvPr/>
+        </p:nvSpPr>
+        <p:spPr>
+          <a:xfrm>
+            <a:off x="1380744" y="3616452"/>
+            <a:ext cx="950976" cy="201168"/>
+          </a:xfrm>
+          <a:prstGeom prst="rect">
+            <a:avLst/>
+          </a:prstGeom>
+          <a:noFill/>
+          <a:ln/>
+        </p:spPr>
+        <p:txBody>
+          <a:bodyPr wrap="square" lIns="0" tIns="0" rIns="0" bIns="0" rtlCol="0" anchor="ctr"/>
+          <a:lstStyle/>
+          <a:p>
+            <a:pPr algn="ctr" indent="0" marL="0">
+              <a:buNone/>
+            </a:pPr>
+            <a:r>
+              <a:rPr lang="en-US" sz="750" b="1" dirty="0">
+                <a:solidFill>
+                  <a:srgbClr val="000000"/>
+                </a:solidFill>
+                <a:latin typeface="Arial" pitchFamily="34" charset="0"/>
+                <a:ea typeface="Arial" pitchFamily="34" charset="-122"/>
+                <a:cs typeface="Arial" pitchFamily="34" charset="-120"/>
+              </a:rPr>
+              <a:t>50 m</a:t>
+            </a:r>
+            <a:endParaRPr lang="en-US" sz="750" dirty="0"/>
+          </a:p>
+        </p:txBody>
+      </p:sp>
+      <p:sp>
+        <p:nvSpPr>
+          <p:cNvPr id="2069" name="Shape 2069"/>
+          <p:cNvSpPr txBox="1"/>
+          <p:nvPr/>
+        </p:nvSpPr>
+        <p:spPr>
+          <a:xfrm>
+            <a:off x="2386584" y="3616452"/>
+            <a:ext cx="950976" cy="201168"/>
+          </a:xfrm>
+          <a:prstGeom prst="rect">
+            <a:avLst/>
+          </a:prstGeom>
+          <a:noFill/>
+          <a:ln/>
+        </p:spPr>
+        <p:txBody>
+          <a:bodyPr wrap="square" lIns="0" tIns="0" rIns="0" bIns="0" rtlCol="0" anchor="ctr"/>
+          <a:lstStyle/>
+          <a:p>
+            <a:pPr algn="ctr" indent="0" marL="0">
+              <a:buNone/>
+            </a:pPr>
+            <a:r>
+              <a:rPr lang="en-US" sz="750" b="1" dirty="0">
+                <a:solidFill>
+                  <a:srgbClr val="000000"/>
+                </a:solidFill>
+                <a:latin typeface="Arial" pitchFamily="34" charset="0"/>
+                <a:ea typeface="Arial" pitchFamily="34" charset="-122"/>
+                <a:cs typeface="Arial" pitchFamily="34" charset="-120"/>
+              </a:rPr>
+              <a:t>883 m</a:t>
+            </a:r>
+            <a:endParaRPr lang="en-US" sz="750" dirty="0"/>
+          </a:p>
+        </p:txBody>
+      </p:sp>
+      <p:sp>
+        <p:nvSpPr>
+          <p:cNvPr id="2070" name="Shape 2070"/>
+          <p:cNvSpPr txBox="1"/>
+          <p:nvPr/>
+        </p:nvSpPr>
+        <p:spPr>
+          <a:xfrm>
+            <a:off x="3392424" y="3616452"/>
+            <a:ext cx="1133856" cy="201168"/>
+          </a:xfrm>
+          <a:prstGeom prst="rect">
+            <a:avLst/>
+          </a:prstGeom>
+          <a:noFill/>
+          <a:ln/>
+        </p:spPr>
+        <p:txBody>
+          <a:bodyPr wrap="square" lIns="0" tIns="0" rIns="0" bIns="0" rtlCol="0" anchor="ctr"/>
+          <a:lstStyle/>
+          <a:p>
+            <a:pPr algn="ctr" indent="0" marL="0">
+              <a:buNone/>
+            </a:pPr>
+            <a:r>
+              <a:rPr lang="en-US" sz="750" b="1" dirty="0">
+                <a:solidFill>
+                  <a:srgbClr val="000000"/>
+                </a:solidFill>
+                <a:latin typeface="Arial" pitchFamily="34" charset="0"/>
+                <a:ea typeface="Arial" pitchFamily="34" charset="-122"/>
+                <a:cs typeface="Arial" pitchFamily="34" charset="-120"/>
+              </a:rPr>
+              <a:t>$5.416.332</a:t>
+            </a:r>
+            <a:endParaRPr lang="en-US" sz="750" dirty="0"/>
+          </a:p>
+        </p:txBody>
+      </p:sp>
+      <p:sp>
+        <p:nvSpPr>
+          <p:cNvPr id="2071" name="Shape 2071"/>
+          <p:cNvSpPr txBox="1"/>
+          <p:nvPr/>
+        </p:nvSpPr>
+        <p:spPr>
+          <a:xfrm>
+            <a:off x="164592" y="3973068"/>
+            <a:ext cx="4389120" cy="731520"/>
+          </a:xfrm>
+          <a:prstGeom prst="rect">
+            <a:avLst/>
+          </a:prstGeom>
+          <a:noFill/>
+          <a:ln/>
+        </p:spPr>
+        <p:txBody>
+          <a:bodyPr wrap="square" lIns="0" tIns="0" rIns="0" bIns="0" rtlCol="0" anchor="t"/>
+          <a:lstStyle/>
+          <a:p>
+            <a:pPr algn="l" indent="0" marL="0">
+              <a:buNone/>
+            </a:pPr>
+            <a:r>
+              <a:rPr lang="en-US" sz="700" i="1" dirty="0">
+                <a:solidFill>
+                  <a:srgbClr val="9A9A9A"/>
+                </a:solidFill>
+                <a:latin typeface="Arial" pitchFamily="34" charset="0"/>
+                <a:ea typeface="Arial" pitchFamily="34" charset="-122"/>
+                <a:cs typeface="Arial" pitchFamily="34" charset="-120"/>
+              </a:rPr>
+              <a:t>* Julio extrapolado (245 m) con la misma proporción de etapas del resto del período (5,4% antes de sublimar).</a:t>
+            </a:r>
+            <a:endParaRPr lang="en-US" sz="700" dirty="0"/>
+          </a:p>
+          <a:p>
+            <a:pPr algn="l" indent="0" marL="0">
+              <a:buNone/>
+            </a:pPr>
+            <a:r>
+              <a:rPr lang="en-US" sz="700" i="1" dirty="0">
+                <a:solidFill>
+                  <a:srgbClr val="9A9A9A"/>
+                </a:solidFill>
+                <a:latin typeface="Arial" pitchFamily="34" charset="0"/>
+                <a:ea typeface="Arial" pitchFamily="34" charset="-122"/>
+                <a:cs typeface="Arial" pitchFamily="34" charset="-120"/>
+              </a:rPr>
+              <a:t>Se marca "antes de sublimar" sólo con evidencia en el chat WA o en el Control de Ploteo (pieza que no venía en la impresión, o reproceso frenado a tiempo). Si no hay claridad se asume reproceso completo. Corte no valorizado.</a:t>
+            </a:r>
+            <a:endParaRPr lang="en-US" sz="700" dirty="0"/>
+          </a:p>
+        </p:txBody>
+      </p:sp>
+      <p:sp>
+        <p:nvSpPr>
+          <p:cNvPr id="2072" name="Shape 2072"/>
+          <p:cNvSpPr/>
+          <p:nvPr/>
+        </p:nvSpPr>
+        <p:spPr>
+          <a:xfrm>
+            <a:off x="4846320" y="1938528"/>
+            <a:ext cx="2011680" cy="914400"/>
+          </a:xfrm>
+          <a:prstGeom prst="rect">
+            <a:avLst/>
+          </a:prstGeom>
+          <a:solidFill>
+            <a:srgbClr val="2D2D2D"/>
+          </a:solidFill>
+          <a:ln/>
+        </p:spPr>
+        <p:txBody>
+          <a:bodyPr/>
+          <a:p/>
+        </p:txBody>
+      </p:sp>
+      <p:sp>
+        <p:nvSpPr>
+          <p:cNvPr id="2073" name="Shape 2073"/>
+          <p:cNvSpPr/>
+          <p:nvPr/>
+        </p:nvSpPr>
+        <p:spPr>
+          <a:xfrm>
+            <a:off x="4846320" y="1938528"/>
+            <a:ext cx="2011680" cy="45720"/>
+          </a:xfrm>
+          <a:prstGeom prst="rect">
+            <a:avLst/>
+          </a:prstGeom>
+          <a:solidFill>
+            <a:srgbClr val="1B7F4A"/>
+          </a:solidFill>
+          <a:ln/>
+        </p:spPr>
+        <p:txBody>
+          <a:bodyPr/>
+          <a:p/>
+        </p:txBody>
+      </p:sp>
+      <p:sp>
+        <p:nvSpPr>
+          <p:cNvPr id="2074" name="Shape 2074"/>
+          <p:cNvSpPr txBox="1"/>
+          <p:nvPr/>
+        </p:nvSpPr>
+        <p:spPr>
+          <a:xfrm>
+            <a:off x="4974336" y="2048256"/>
+            <a:ext cx="1755648" cy="201168"/>
+          </a:xfrm>
+          <a:prstGeom prst="rect">
+            <a:avLst/>
+          </a:prstGeom>
+          <a:noFill/>
+          <a:ln/>
+        </p:spPr>
+        <p:txBody>
+          <a:bodyPr wrap="square" lIns="0" tIns="0" rIns="0" bIns="0" rtlCol="0" anchor="t"/>
+          <a:lstStyle/>
+          <a:p>
+            <a:pPr algn="l" indent="0" marL="0">
+              <a:buNone/>
+            </a:pPr>
+            <a:r>
+              <a:rPr lang="en-US" sz="750" b="1" dirty="0">
+                <a:solidFill>
+                  <a:srgbClr val="9A9A9A"/>
+                </a:solidFill>
+                <a:latin typeface="Arial" pitchFamily="34" charset="0"/>
+                <a:ea typeface="Arial" pitchFamily="34" charset="-122"/>
+                <a:cs typeface="Arial" pitchFamily="34" charset="-120"/>
+              </a:rPr>
+              <a:t>SOLO REIMPRESIÓN</a:t>
+            </a:r>
+            <a:endParaRPr lang="en-US" sz="750" dirty="0"/>
+          </a:p>
+        </p:txBody>
+      </p:sp>
+      <p:sp>
+        <p:nvSpPr>
+          <p:cNvPr id="2075" name="Shape 2075"/>
+          <p:cNvSpPr txBox="1"/>
+          <p:nvPr/>
+        </p:nvSpPr>
+        <p:spPr>
+          <a:xfrm>
+            <a:off x="4974336" y="2231136"/>
+            <a:ext cx="1755648" cy="384048"/>
+          </a:xfrm>
+          <a:prstGeom prst="rect">
+            <a:avLst/>
+          </a:prstGeom>
+          <a:noFill/>
+          <a:ln/>
+        </p:spPr>
+        <p:txBody>
+          <a:bodyPr wrap="square" lIns="0" tIns="0" rIns="0" bIns="0" rtlCol="0" anchor="t"/>
+          <a:lstStyle/>
+          <a:p>
+            <a:pPr algn="l" indent="0" marL="0">
+              <a:buNone/>
+            </a:pPr>
+            <a:r>
+              <a:rPr lang="en-US" sz="1800" b="1" dirty="0">
+                <a:solidFill>
+                  <a:srgbClr val="27AE60"/>
+                </a:solidFill>
+                <a:latin typeface="Arial" pitchFamily="34" charset="0"/>
+                <a:ea typeface="Arial" pitchFamily="34" charset="-122"/>
+                <a:cs typeface="Arial" pitchFamily="34" charset="-120"/>
+              </a:rPr>
+              <a:t>$120.912</a:t>
+            </a:r>
+            <a:endParaRPr lang="en-US" sz="2200" dirty="0"/>
+          </a:p>
+        </p:txBody>
+      </p:sp>
+      <p:sp>
+        <p:nvSpPr>
+          <p:cNvPr id="2076" name="Shape 2076"/>
+          <p:cNvSpPr txBox="1"/>
+          <p:nvPr/>
+        </p:nvSpPr>
+        <p:spPr>
+          <a:xfrm>
+            <a:off x="4974336" y="2596896"/>
+            <a:ext cx="1755648" cy="201168"/>
+          </a:xfrm>
+          <a:prstGeom prst="rect">
+            <a:avLst/>
+          </a:prstGeom>
+          <a:noFill/>
+          <a:ln/>
+        </p:spPr>
+        <p:txBody>
+          <a:bodyPr wrap="square" lIns="0" tIns="0" rIns="0" bIns="0" rtlCol="0" anchor="t"/>
+          <a:lstStyle/>
+          <a:p>
+            <a:pPr algn="l" indent="0" marL="0">
+              <a:buNone/>
+            </a:pPr>
+            <a:r>
+              <a:rPr lang="en-US" sz="800" i="1" dirty="0">
+                <a:solidFill>
+                  <a:srgbClr val="9A9A9A"/>
+                </a:solidFill>
+                <a:latin typeface="Arial" pitchFamily="34" charset="0"/>
+                <a:ea typeface="Arial" pitchFamily="34" charset="-122"/>
+                <a:cs typeface="Arial" pitchFamily="34" charset="-120"/>
+              </a:rPr>
+              <a:t>50 m · 5% de los metros</a:t>
+            </a:r>
+            <a:endParaRPr lang="en-US" sz="800" dirty="0"/>
+          </a:p>
+        </p:txBody>
+      </p:sp>
+      <p:sp>
+        <p:nvSpPr>
+          <p:cNvPr id="2077" name="Shape 2077"/>
+          <p:cNvSpPr/>
+          <p:nvPr/>
+        </p:nvSpPr>
+        <p:spPr>
+          <a:xfrm>
+            <a:off x="6967728" y="1938528"/>
+            <a:ext cx="2011680" cy="914400"/>
+          </a:xfrm>
+          <a:prstGeom prst="rect">
+            <a:avLst/>
+          </a:prstGeom>
+          <a:solidFill>
+            <a:srgbClr val="2D2D2D"/>
+          </a:solidFill>
+          <a:ln/>
+        </p:spPr>
+        <p:txBody>
+          <a:bodyPr/>
+          <a:p/>
+        </p:txBody>
+      </p:sp>
+      <p:sp>
+        <p:nvSpPr>
+          <p:cNvPr id="2078" name="Shape 2078"/>
+          <p:cNvSpPr/>
+          <p:nvPr/>
+        </p:nvSpPr>
+        <p:spPr>
+          <a:xfrm>
+            <a:off x="6967728" y="1938528"/>
+            <a:ext cx="2011680" cy="45720"/>
+          </a:xfrm>
+          <a:prstGeom prst="rect">
+            <a:avLst/>
+          </a:prstGeom>
+          <a:solidFill>
+            <a:srgbClr val="ED6C23"/>
+          </a:solidFill>
+          <a:ln/>
+        </p:spPr>
+        <p:txBody>
+          <a:bodyPr/>
+          <a:p/>
+        </p:txBody>
+      </p:sp>
+      <p:sp>
+        <p:nvSpPr>
+          <p:cNvPr id="2079" name="Shape 2079"/>
+          <p:cNvSpPr txBox="1"/>
+          <p:nvPr/>
+        </p:nvSpPr>
+        <p:spPr>
+          <a:xfrm>
+            <a:off x="7095744" y="2048256"/>
+            <a:ext cx="1755648" cy="201168"/>
+          </a:xfrm>
+          <a:prstGeom prst="rect">
+            <a:avLst/>
+          </a:prstGeom>
+          <a:noFill/>
+          <a:ln/>
+        </p:spPr>
+        <p:txBody>
+          <a:bodyPr wrap="square" lIns="0" tIns="0" rIns="0" bIns="0" rtlCol="0" anchor="t"/>
+          <a:lstStyle/>
+          <a:p>
+            <a:pPr algn="l" indent="0" marL="0">
+              <a:buNone/>
+            </a:pPr>
+            <a:r>
+              <a:rPr lang="en-US" sz="750" b="1" dirty="0">
+                <a:solidFill>
+                  <a:srgbClr val="9A9A9A"/>
+                </a:solidFill>
+                <a:latin typeface="Arial" pitchFamily="34" charset="0"/>
+                <a:ea typeface="Arial" pitchFamily="34" charset="-122"/>
+                <a:cs typeface="Arial" pitchFamily="34" charset="-120"/>
+              </a:rPr>
+              <a:t>REPROCESO COMPLETO</a:t>
+            </a:r>
+            <a:endParaRPr lang="en-US" sz="750" dirty="0"/>
+          </a:p>
+        </p:txBody>
+      </p:sp>
+      <p:sp>
+        <p:nvSpPr>
+          <p:cNvPr id="2080" name="Shape 2080"/>
+          <p:cNvSpPr txBox="1"/>
+          <p:nvPr/>
+        </p:nvSpPr>
+        <p:spPr>
+          <a:xfrm>
+            <a:off x="7095744" y="2231136"/>
+            <a:ext cx="1755648" cy="384048"/>
+          </a:xfrm>
+          <a:prstGeom prst="rect">
+            <a:avLst/>
+          </a:prstGeom>
+          <a:noFill/>
+          <a:ln/>
+        </p:spPr>
+        <p:txBody>
+          <a:bodyPr wrap="square" lIns="0" tIns="0" rIns="0" bIns="0" rtlCol="0" anchor="t"/>
+          <a:lstStyle/>
+          <a:p>
+            <a:pPr algn="l" indent="0" marL="0">
+              <a:buNone/>
+            </a:pPr>
+            <a:r>
+              <a:rPr lang="en-US" sz="1800" b="1" dirty="0">
+                <a:solidFill>
+                  <a:srgbClr val="ED6C23"/>
+                </a:solidFill>
+                <a:latin typeface="Arial" pitchFamily="34" charset="0"/>
+                <a:ea typeface="Arial" pitchFamily="34" charset="-122"/>
+                <a:cs typeface="Arial" pitchFamily="34" charset="-120"/>
+              </a:rPr>
+              <a:t>$5.295.420</a:t>
+            </a:r>
+            <a:endParaRPr lang="en-US" sz="2200" dirty="0"/>
+          </a:p>
+        </p:txBody>
+      </p:sp>
+      <p:sp>
+        <p:nvSpPr>
+          <p:cNvPr id="2081" name="Shape 2081"/>
+          <p:cNvSpPr txBox="1"/>
+          <p:nvPr/>
+        </p:nvSpPr>
+        <p:spPr>
+          <a:xfrm>
+            <a:off x="7095744" y="2596896"/>
+            <a:ext cx="1755648" cy="201168"/>
+          </a:xfrm>
+          <a:prstGeom prst="rect">
+            <a:avLst/>
+          </a:prstGeom>
+          <a:noFill/>
+          <a:ln/>
+        </p:spPr>
+        <p:txBody>
+          <a:bodyPr wrap="square" lIns="0" tIns="0" rIns="0" bIns="0" rtlCol="0" anchor="t"/>
+          <a:lstStyle/>
+          <a:p>
+            <a:pPr algn="l" indent="0" marL="0">
+              <a:buNone/>
+            </a:pPr>
+            <a:r>
+              <a:rPr lang="en-US" sz="800" i="1" dirty="0">
+                <a:solidFill>
+                  <a:srgbClr val="9A9A9A"/>
+                </a:solidFill>
+                <a:latin typeface="Arial" pitchFamily="34" charset="0"/>
+                <a:ea typeface="Arial" pitchFamily="34" charset="-122"/>
+                <a:cs typeface="Arial" pitchFamily="34" charset="-120"/>
+              </a:rPr>
+              <a:t>883 m · 95% de los metros</a:t>
+            </a:r>
+            <a:endParaRPr lang="en-US" sz="800" dirty="0"/>
+          </a:p>
+        </p:txBody>
+      </p:sp>
+      <p:sp>
+        <p:nvSpPr>
+          <p:cNvPr id="2082" name="Shape 2082"/>
+          <p:cNvSpPr/>
+          <p:nvPr/>
+        </p:nvSpPr>
+        <p:spPr>
+          <a:xfrm>
+            <a:off x="4846320" y="2980944"/>
+            <a:ext cx="4133088" cy="841248"/>
+          </a:xfrm>
+          <a:prstGeom prst="rect">
+            <a:avLst/>
+          </a:prstGeom>
+          <a:solidFill>
+            <a:srgbClr val="ED6C23"/>
+          </a:solidFill>
+          <a:ln/>
+        </p:spPr>
+      </p:sp>
+      <p:sp>
+        <p:nvSpPr>
+          <p:cNvPr id="2083" name="Shape 2083"/>
+          <p:cNvSpPr txBox="1"/>
+          <p:nvPr/>
+        </p:nvSpPr>
+        <p:spPr>
+          <a:xfrm>
+            <a:off x="4983480" y="3035808"/>
+            <a:ext cx="3858768" cy="749808"/>
+          </a:xfrm>
+          <a:prstGeom prst="rect">
+            <a:avLst/>
+          </a:prstGeom>
+          <a:noFill/>
+          <a:ln/>
+        </p:spPr>
+        <p:txBody>
+          <a:bodyPr wrap="square" lIns="0" tIns="0" rIns="0" bIns="0" rtlCol="0" anchor="t"/>
+          <a:lstStyle/>
+          <a:p>
+            <a:pPr algn="l" indent="0" marL="0">
+              <a:buNone/>
+            </a:pPr>
+            <a:r>
+              <a:rPr lang="en-US" sz="950" b="1" dirty="0">
+                <a:solidFill>
+                  <a:srgbClr val="000000"/>
+                </a:solidFill>
+                <a:latin typeface="Arial" pitchFamily="34" charset="0"/>
+                <a:ea typeface="Arial" pitchFamily="34" charset="-122"/>
+                <a:cs typeface="Arial" pitchFamily="34" charset="-120"/>
+              </a:rPr>
+              <a:t>DETECTAR ANTES DE SUBLIMAR AHORRÓ $181.368</a:t>
+            </a:r>
+            <a:endParaRPr lang="en-US" sz="750" dirty="0"/>
+          </a:p>
+          <a:p>
+            <a:pPr algn="l" indent="0" marL="0">
+              <a:spcBef>
+                <a:spcPts val="300"/>
+              </a:spcBef>
+              <a:buNone/>
+            </a:pPr>
+            <a:r>
+              <a:rPr lang="en-US" sz="800" dirty="0">
+                <a:solidFill>
+                  <a:srgbClr val="000000"/>
+                </a:solidFill>
+                <a:latin typeface="Arial" pitchFamily="34" charset="0"/>
+                <a:ea typeface="Arial" pitchFamily="34" charset="-122"/>
+                <a:cs typeface="Arial" pitchFamily="34" charset="-120"/>
+              </a:rPr>
+              <a:t>Sólo 50 m (5%) tienen evidencia de haberse frenado antes de sublimar. Cada metro frenado a tiempo ahorra $3.600: registrar la etapa en cada reproceso.</a:t>
+            </a:r>
+            <a:endParaRPr lang="en-US" sz="750" dirty="0"/>
+          </a:p>
+        </p:txBody>
+      </p:sp>
+      <p:sp>
+        <p:nvSpPr>
+          <p:cNvPr id="2084" name="Shape 2084"/>
+          <p:cNvSpPr/>
+          <p:nvPr/>
+        </p:nvSpPr>
+        <p:spPr>
+          <a:xfrm>
+            <a:off x="4846320" y="3931920"/>
+            <a:ext cx="4133088" cy="804672"/>
+          </a:xfrm>
+          <a:prstGeom prst="rect">
+            <a:avLst/>
+          </a:prstGeom>
+          <a:solidFill>
+            <a:srgbClr val="1A1A1A"/>
+          </a:solidFill>
+          <a:ln/>
+        </p:spPr>
+        <p:txBody>
+          <a:bodyPr/>
+          <a:p/>
+        </p:txBody>
+      </p:sp>
+      <p:sp>
+        <p:nvSpPr>
+          <p:cNvPr id="2085" name="Shape 2085"/>
+          <p:cNvSpPr txBox="1"/>
+          <p:nvPr/>
+        </p:nvSpPr>
+        <p:spPr>
+          <a:xfrm>
+            <a:off x="4983480" y="3995928"/>
+            <a:ext cx="3858768" cy="201168"/>
+          </a:xfrm>
+          <a:prstGeom prst="rect">
+            <a:avLst/>
+          </a:prstGeom>
+          <a:noFill/>
+          <a:ln/>
+        </p:spPr>
+        <p:txBody>
+          <a:bodyPr wrap="square" lIns="0" tIns="0" rIns="0" bIns="0" rtlCol="0" anchor="t"/>
+          <a:lstStyle/>
+          <a:p>
+            <a:pPr algn="l" indent="0" marL="0">
+              <a:buNone/>
+            </a:pPr>
+            <a:r>
+              <a:rPr lang="en-US" sz="750" b="1" dirty="0">
+                <a:solidFill>
+                  <a:srgbClr val="9A9A9A"/>
+                </a:solidFill>
+                <a:latin typeface="Arial" pitchFamily="34" charset="0"/>
+                <a:ea typeface="Arial" pitchFamily="34" charset="-122"/>
+                <a:cs typeface="Arial" pitchFamily="34" charset="-120"/>
+              </a:rPr>
+              <a:t>COSTO TOTAL MAY–SEP (SEGÚN ETAPA)</a:t>
+            </a:r>
+            <a:endParaRPr lang="en-US" sz="750" dirty="0"/>
+          </a:p>
+        </p:txBody>
+      </p:sp>
+      <p:sp>
+        <p:nvSpPr>
+          <p:cNvPr id="2086" name="Shape 2086"/>
+          <p:cNvSpPr txBox="1"/>
+          <p:nvPr/>
+        </p:nvSpPr>
+        <p:spPr>
+          <a:xfrm>
+            <a:off x="4983480" y="4160520"/>
+            <a:ext cx="3858768" cy="329184"/>
+          </a:xfrm>
+          <a:prstGeom prst="rect">
+            <a:avLst/>
+          </a:prstGeom>
+          <a:noFill/>
+          <a:ln/>
+        </p:spPr>
+        <p:txBody>
+          <a:bodyPr wrap="square" lIns="0" tIns="0" rIns="0" bIns="0" rtlCol="0" anchor="t"/>
+          <a:lstStyle/>
+          <a:p>
+            <a:pPr algn="l" indent="0" marL="0">
+              <a:buNone/>
+            </a:pPr>
+            <a:r>
+              <a:rPr lang="en-US" sz="1600" b="1" dirty="0">
+                <a:solidFill>
+                  <a:srgbClr val="ED6C23"/>
+                </a:solidFill>
+                <a:latin typeface="Arial" pitchFamily="34" charset="0"/>
+                <a:ea typeface="Arial" pitchFamily="34" charset="-122"/>
+                <a:cs typeface="Arial" pitchFamily="34" charset="-120"/>
+              </a:rPr>
+              <a:t>$5.416.332 CLP</a:t>
+            </a:r>
+            <a:endParaRPr lang="en-US" sz="2200" dirty="0"/>
+          </a:p>
+        </p:txBody>
+      </p:sp>
+      <p:sp>
+        <p:nvSpPr>
+          <p:cNvPr id="2087" name="Shape 2087"/>
+          <p:cNvSpPr txBox="1"/>
+          <p:nvPr/>
+        </p:nvSpPr>
+        <p:spPr>
+          <a:xfrm>
+            <a:off x="4983480" y="4498848"/>
+            <a:ext cx="3858768" cy="182880"/>
+          </a:xfrm>
+          <a:prstGeom prst="rect">
+            <a:avLst/>
+          </a:prstGeom>
+          <a:noFill/>
+          <a:ln/>
+        </p:spPr>
+        <p:txBody>
+          <a:bodyPr wrap="square" lIns="0" tIns="0" rIns="0" bIns="0" rtlCol="0" anchor="t"/>
+          <a:lstStyle/>
+          <a:p>
+            <a:pPr algn="l" indent="0" marL="0">
+              <a:buNone/>
+            </a:pPr>
+            <a:r>
+              <a:rPr lang="en-US" sz="750" i="1" dirty="0">
+                <a:solidFill>
+                  <a:srgbClr val="9A9A9A"/>
+                </a:solidFill>
+                <a:latin typeface="Arial" pitchFamily="34" charset="0"/>
+                <a:ea typeface="Arial" pitchFamily="34" charset="-122"/>
+                <a:cs typeface="Arial" pitchFamily="34" charset="-120"/>
+              </a:rPr>
+              <a:t>Si todo se contara como reproceso completo: $5.597.700</a:t>
+            </a:r>
+            <a:endParaRPr lang="en-US" sz="800" dirty="0"/>
           </a:p>
         </p:txBody>
       </p:sp>

</xml_diff>